<commit_message>
Capturas de la consola de Athena en el informe y la presentacion
Co-Authored-By: Claude Sonnet 5 <noreply@anthropic.com>
</commit_message>
<xml_diff>
--- a/entregables/Presentacion-Delivery-Cloud.pptx
+++ b/entregables/Presentacion-Delivery-Cloud.pptx
@@ -21,9 +21,10 @@
     <p:sldId id="269" r:id="rId15"/>
     <p:sldId id="270" r:id="rId16"/>
     <p:sldId id="271" r:id="rId17"/>
+    <p:sldId id="272" r:id="rId18"/>
   </p:sldIdLst>
   <p:notesMasterIdLst>
-    <p:notesMasterId r:id="rId18"/>
+    <p:notesMasterId r:id="rId19"/>
   </p:notesMasterIdLst>
   <p:sldSz cx="9144000" cy="5143500"/>
   <p:notesSz cx="5143500" cy="9144000"/>
@@ -1098,7 +1099,7 @@
           <a:p>
             <a:r>
               <a:rPr lang="en-US" dirty="0"/>
-              <a:t>El paginado se agregó sin romper a los consumidores: sin parámetros el comportamiento es el de siempre.</a:t>
+              <a:t>Capturas reales de la consola de Amazon Athena con el workgroup pp-workgroup.</a:t>
             </a:r>
             <a:endParaRPr lang="en-US" dirty="0"/>
           </a:p>
@@ -1186,7 +1187,7 @@
           <a:p>
             <a:r>
               <a:rPr lang="en-US" dirty="0"/>
-              <a:t>Las pruebas se ejecutaron en local y contra AWS a través del API Gateway.</a:t>
+              <a:t>El paginado se agregó sin romper a los consumidores: sin parámetros el comportamiento es el de siempre.</a:t>
             </a:r>
             <a:endParaRPr lang="en-US" dirty="0"/>
           </a:p>
@@ -1274,7 +1275,7 @@
           <a:p>
             <a:r>
               <a:rPr lang="en-US" dirty="0"/>
-              <a:t>Limitaciones conocidas y mejoras planeadas.</a:t>
+              <a:t>Las pruebas se ejecutaron en local y contra AWS a través del API Gateway.</a:t>
             </a:r>
             <a:endParaRPr lang="en-US" dirty="0"/>
           </a:p>
@@ -1362,7 +1363,7 @@
           <a:p>
             <a:r>
               <a:rPr lang="en-US" dirty="0"/>
-              <a:t/>
+              <a:t>Limitaciones conocidas y mejoras planeadas.</a:t>
             </a:r>
             <a:endParaRPr lang="en-US" dirty="0"/>
           </a:p>
@@ -1386,6 +1387,94 @@
             <a:fld id="{F7021451-1387-4CA6-816F-3879F97B5CBC}" type="slidenum">
               <a:rPr lang="en-US"/>
               <a:t>16</a:t>
+            </a:fld>
+            <a:endParaRPr lang="en-US"/>
+          </a:p>
+        </p:txBody>
+      </p:sp>
+    </p:spTree>
+    <p:extLst>
+      <p:ext uri="{BB962C8B-B14F-4D97-AF65-F5344CB8AC3E}">
+        <p14:creationId xmlns:p14="http://schemas.microsoft.com/office/powerpoint/2010/main" val="1024086991"/>
+      </p:ext>
+    </p:extLst>
+  </p:cSld>
+  <p:clrMapOvr>
+    <a:masterClrMapping/>
+  </p:clrMapOvr>
+</p:notes>
+</file>
+
+<file path=ppt/notesSlides/notesSlide17.xml><?xml version="1.0" encoding="utf-8"?>
+<p:notes xmlns:a="http://schemas.openxmlformats.org/drawingml/2006/main" xmlns:r="http://schemas.openxmlformats.org/officeDocument/2006/relationships" xmlns:p="http://schemas.openxmlformats.org/presentationml/2006/main">
+  <p:cSld>
+    <p:spTree>
+      <p:nvGrpSpPr>
+        <p:cNvPr id="1" name=""/>
+        <p:cNvGrpSpPr/>
+        <p:nvPr/>
+      </p:nvGrpSpPr>
+      <p:grpSpPr>
+        <a:xfrm>
+          <a:off x="0" y="0"/>
+          <a:ext cx="0" cy="0"/>
+          <a:chOff x="0" y="0"/>
+          <a:chExt cx="0" cy="0"/>
+        </a:xfrm>
+      </p:grpSpPr>
+      <p:sp>
+        <p:nvSpPr>
+          <p:cNvPr id="2" name="Slide Image Placeholder 1"/>
+          <p:cNvSpPr>
+            <a:spLocks noGrp="1" noRot="1" noChangeAspect="1"/>
+          </p:cNvSpPr>
+          <p:nvPr>
+            <p:ph type="sldImg"/>
+          </p:nvPr>
+        </p:nvSpPr>
+        <p:spPr/>
+      </p:sp>
+      <p:sp>
+        <p:nvSpPr>
+          <p:cNvPr id="3" name="Notes Placeholder 2"/>
+          <p:cNvSpPr>
+            <a:spLocks noGrp="1"/>
+          </p:cNvSpPr>
+          <p:nvPr>
+            <p:ph type="body" idx="1"/>
+          </p:nvPr>
+        </p:nvSpPr>
+        <p:spPr/>
+        <p:txBody>
+          <a:bodyPr/>
+          <a:lstStyle/>
+          <a:p>
+            <a:r>
+              <a:rPr lang="en-US" dirty="0"/>
+              <a:t/>
+            </a:r>
+            <a:endParaRPr lang="en-US" dirty="0"/>
+          </a:p>
+        </p:txBody>
+      </p:sp>
+      <p:sp>
+        <p:nvSpPr>
+          <p:cNvPr id="4" name="Slide Number Placeholder 3"/>
+          <p:cNvSpPr>
+            <a:spLocks noGrp="1"/>
+          </p:cNvSpPr>
+          <p:nvPr>
+            <p:ph type="sldNum" sz="quarter" idx="10"/>
+          </p:nvPr>
+        </p:nvSpPr>
+        <p:spPr/>
+        <p:txBody>
+          <a:bodyPr/>
+          <a:lstStyle/>
+          <a:p>
+            <a:fld id="{F7021451-1387-4CA6-816F-3879F97B5CBC}" type="slidenum">
+              <a:rPr lang="en-US"/>
+              <a:t>17</a:t>
             </a:fld>
             <a:endParaRPr lang="en-US"/>
           </a:p>
@@ -5881,7 +5970,7 @@
                 <a:ea typeface="Calibri" pitchFamily="34" charset="-122"/>
                 <a:cs typeface="Calibri" pitchFamily="34" charset="-120"/>
               </a:rPr>
-              <a:t>Paginado opcional: de megabytes a kilobytes</a:t>
+              <a:t>Evidencia en la consola de Athena</a:t>
             </a:r>
             <a:endParaRPr lang="en-US" sz="2800" dirty="0"/>
           </a:p>
@@ -5920,22 +6009,53 @@
                 <a:ea typeface="Calibri" pitchFamily="34" charset="-122"/>
                 <a:cs typeface="Calibri" pitchFamily="34" charset="-120"/>
               </a:rPr>
-              <a:t>Misma ruta, dos modos: sin parámetros devuelve todo; con ?page= y ?page_size= devuelve una página</a:t>
+              <a:t>Capturas de las consultas y vistas ejecutadas sobre el data lake</a:t>
             </a:r>
             <a:endParaRPr lang="en-US" sz="1400" dirty="0"/>
           </a:p>
         </p:txBody>
       </p:sp>
-      <p:sp>
-        <p:nvSpPr>
-          <p:cNvPr id="4" name="Text 2"/>
-          <p:cNvSpPr txBox="1"/>
-          <p:nvPr/>
-        </p:nvSpPr>
-        <p:spPr>
-          <a:xfrm>
-            <a:off x="3291840" y="1417320"/>
-            <a:ext cx="2468880" cy="320040"/>
+      <p:pic>
+        <p:nvPicPr>
+          <p:cNvPr id="4" name="Image 0" descr="/home/m4ik_1/Documentos/cloudddd/entregables/capturas-athena/consulta-1.png">    </p:cNvPr>
+          <p:cNvPicPr>
+            <a:picLocks noChangeAspect="1"/>
+          </p:cNvPicPr>
+          <p:nvPr/>
+        </p:nvPicPr>
+        <p:blipFill>
+          <a:blip r:embed="rId1"/>
+          <a:stretch>
+            <a:fillRect/>
+          </a:stretch>
+        </p:blipFill>
+        <p:spPr>
+          <a:xfrm>
+            <a:off x="1691640" y="1280160"/>
+            <a:ext cx="2743200" cy="1543050"/>
+          </a:xfrm>
+          <a:prstGeom prst="rect">
+            <a:avLst/>
+          </a:prstGeom>
+          <a:effectLst>
+            <a:outerShdw sx="100000" sy="100000" kx="0" ky="0" algn="bl" rotWithShape="0" blurRad="101600" dist="25400" dir="5400000">
+              <a:srgbClr val="000000">
+                <a:alpha val="15000"/>
+              </a:srgbClr>
+            </a:outerShdw>
+          </a:effectLst>
+        </p:spPr>
+      </p:pic>
+      <p:sp>
+        <p:nvSpPr>
+          <p:cNvPr id="5" name="Text 2"/>
+          <p:cNvSpPr txBox="1"/>
+          <p:nvPr/>
+        </p:nvSpPr>
+        <p:spPr>
+          <a:xfrm>
+            <a:off x="1691640" y="2868930"/>
+            <a:ext cx="2743200" cy="256032"/>
           </a:xfrm>
           <a:prstGeom prst="rect">
             <a:avLst/>
@@ -5951,30 +6071,61 @@
               <a:buNone/>
             </a:pPr>
             <a:r>
-              <a:rPr lang="en-US" sz="1300" b="1" dirty="0">
-                <a:solidFill>
-                  <a:srgbClr val="5F6B7A"/>
-                </a:solidFill>
-                <a:latin typeface="Calibri" pitchFamily="34" charset="0"/>
-                <a:ea typeface="Calibri" pitchFamily="34" charset="-122"/>
-                <a:cs typeface="Calibri" pitchFamily="34" charset="-120"/>
-              </a:rPr>
-              <a:t>Sin paginar</a:t>
-            </a:r>
-            <a:endParaRPr lang="en-US" sz="1300" dirty="0"/>
-          </a:p>
-        </p:txBody>
-      </p:sp>
-      <p:sp>
-        <p:nvSpPr>
-          <p:cNvPr id="5" name="Text 3"/>
-          <p:cNvSpPr txBox="1"/>
-          <p:nvPr/>
-        </p:nvSpPr>
-        <p:spPr>
-          <a:xfrm>
-            <a:off x="6035040" y="1417320"/>
-            <a:ext cx="2651760" cy="320040"/>
+              <a:rPr lang="en-US" sz="1100" b="1" dirty="0">
+                <a:solidFill>
+                  <a:srgbClr val="232F3E"/>
+                </a:solidFill>
+                <a:latin typeface="Calibri" pitchFamily="34" charset="0"/>
+                <a:ea typeface="Calibri" pitchFamily="34" charset="-122"/>
+                <a:cs typeface="Calibri" pitchFamily="34" charset="-120"/>
+              </a:rPr>
+              <a:t>Consulta 1 · ventas por restaurante</a:t>
+            </a:r>
+            <a:endParaRPr lang="en-US" sz="1100" dirty="0"/>
+          </a:p>
+        </p:txBody>
+      </p:sp>
+      <p:pic>
+        <p:nvPicPr>
+          <p:cNvPr id="6" name="Image 1" descr="/home/m4ik_1/Documentos/cloudddd/entregables/capturas-athena/consulta-2.png">    </p:cNvPr>
+          <p:cNvPicPr>
+            <a:picLocks noChangeAspect="1"/>
+          </p:cNvPicPr>
+          <p:nvPr/>
+        </p:nvPicPr>
+        <p:blipFill>
+          <a:blip r:embed="rId2"/>
+          <a:stretch>
+            <a:fillRect/>
+          </a:stretch>
+        </p:blipFill>
+        <p:spPr>
+          <a:xfrm>
+            <a:off x="4709160" y="1280160"/>
+            <a:ext cx="2743200" cy="1543050"/>
+          </a:xfrm>
+          <a:prstGeom prst="rect">
+            <a:avLst/>
+          </a:prstGeom>
+          <a:effectLst>
+            <a:outerShdw sx="100000" sy="100000" kx="0" ky="0" algn="bl" rotWithShape="0" blurRad="101600" dist="25400" dir="5400000">
+              <a:srgbClr val="000000">
+                <a:alpha val="15000"/>
+              </a:srgbClr>
+            </a:outerShdw>
+          </a:effectLst>
+        </p:spPr>
+      </p:pic>
+      <p:sp>
+        <p:nvSpPr>
+          <p:cNvPr id="7" name="Text 3"/>
+          <p:cNvSpPr txBox="1"/>
+          <p:nvPr/>
+        </p:nvSpPr>
+        <p:spPr>
+          <a:xfrm>
+            <a:off x="4709160" y="2868930"/>
+            <a:ext cx="2743200" cy="256032"/>
           </a:xfrm>
           <a:prstGeom prst="rect">
             <a:avLst/>
@@ -5990,57 +6141,61 @@
               <a:buNone/>
             </a:pPr>
             <a:r>
-              <a:rPr lang="en-US" sz="1300" b="1" dirty="0">
-                <a:solidFill>
-                  <a:srgbClr val="ED7100"/>
-                </a:solidFill>
-                <a:latin typeface="Calibri" pitchFamily="34" charset="0"/>
-                <a:ea typeface="Calibri" pitchFamily="34" charset="-122"/>
-                <a:cs typeface="Calibri" pitchFamily="34" charset="-120"/>
-              </a:rPr>
-              <a:t>Paginado</a:t>
-            </a:r>
-            <a:endParaRPr lang="en-US" sz="1300" dirty="0"/>
-          </a:p>
-        </p:txBody>
-      </p:sp>
-      <p:sp>
-        <p:nvSpPr>
-          <p:cNvPr id="6" name="Shape 4"/>
-          <p:cNvSpPr/>
-          <p:nvPr/>
-        </p:nvSpPr>
-        <p:spPr>
-          <a:xfrm>
-            <a:off x="457200" y="1828800"/>
-            <a:ext cx="8229600" cy="731520"/>
-          </a:xfrm>
-          <a:prstGeom prst="roundRect">
-            <a:avLst>
-              <a:gd name="adj" fmla="val 10000"/>
-            </a:avLst>
-          </a:prstGeom>
-          <a:solidFill>
-            <a:srgbClr val="F2F4F7"/>
-          </a:solidFill>
-          <a:ln w="9525">
-            <a:solidFill>
-              <a:srgbClr val="E1E5EA"/>
-            </a:solidFill>
-            <a:prstDash val="solid"/>
-          </a:ln>
-        </p:spPr>
-      </p:sp>
-      <p:sp>
-        <p:nvSpPr>
-          <p:cNvPr id="7" name="Text 5"/>
-          <p:cNvSpPr txBox="1"/>
-          <p:nvPr/>
-        </p:nvSpPr>
-        <p:spPr>
-          <a:xfrm>
-            <a:off x="640080" y="1828800"/>
-            <a:ext cx="2560320" cy="731520"/>
+              <a:rPr lang="en-US" sz="1100" b="1" dirty="0">
+                <a:solidFill>
+                  <a:srgbClr val="232F3E"/>
+                </a:solidFill>
+                <a:latin typeface="Calibri" pitchFamily="34" charset="0"/>
+                <a:ea typeface="Calibri" pitchFamily="34" charset="-122"/>
+                <a:cs typeface="Calibri" pitchFamily="34" charset="-120"/>
+              </a:rPr>
+              <a:t>Consulta 2 · clientes con mayor gasto</a:t>
+            </a:r>
+            <a:endParaRPr lang="en-US" sz="1100" dirty="0"/>
+          </a:p>
+        </p:txBody>
+      </p:sp>
+      <p:pic>
+        <p:nvPicPr>
+          <p:cNvPr id="8" name="Image 2" descr="/home/m4ik_1/Documentos/cloudddd/entregables/capturas-athena/consulta-3.png">    </p:cNvPr>
+          <p:cNvPicPr>
+            <a:picLocks noChangeAspect="1"/>
+          </p:cNvPicPr>
+          <p:nvPr/>
+        </p:nvPicPr>
+        <p:blipFill>
+          <a:blip r:embed="rId3"/>
+          <a:stretch>
+            <a:fillRect/>
+          </a:stretch>
+        </p:blipFill>
+        <p:spPr>
+          <a:xfrm>
+            <a:off x="1691640" y="3207258"/>
+            <a:ext cx="2743200" cy="1543050"/>
+          </a:xfrm>
+          <a:prstGeom prst="rect">
+            <a:avLst/>
+          </a:prstGeom>
+          <a:effectLst>
+            <a:outerShdw sx="100000" sy="100000" kx="0" ky="0" algn="bl" rotWithShape="0" blurRad="101600" dist="25400" dir="5400000">
+              <a:srgbClr val="000000">
+                <a:alpha val="15000"/>
+              </a:srgbClr>
+            </a:outerShdw>
+          </a:effectLst>
+        </p:spPr>
+      </p:pic>
+      <p:sp>
+        <p:nvSpPr>
+          <p:cNvPr id="9" name="Text 4"/>
+          <p:cNvSpPr txBox="1"/>
+          <p:nvPr/>
+        </p:nvSpPr>
+        <p:spPr>
+          <a:xfrm>
+            <a:off x="1691640" y="4796028"/>
+            <a:ext cx="2743200" cy="256032"/>
           </a:xfrm>
           <a:prstGeom prst="rect">
             <a:avLst/>
@@ -6056,7 +6211,7 @@
               <a:buNone/>
             </a:pPr>
             <a:r>
-              <a:rPr lang="en-US" sz="1500" b="1" dirty="0">
+              <a:rPr lang="en-US" sz="1100" b="1" dirty="0">
                 <a:solidFill>
                   <a:srgbClr val="232F3E"/>
                 </a:solidFill>
@@ -6064,22 +6219,53 @@
                 <a:ea typeface="Calibri" pitchFamily="34" charset="-122"/>
                 <a:cs typeface="Calibri" pitchFamily="34" charset="-120"/>
               </a:rPr>
-              <a:t>Dashboard admin</a:t>
-            </a:r>
-            <a:endParaRPr lang="en-US" sz="1500" dirty="0"/>
-          </a:p>
-        </p:txBody>
-      </p:sp>
-      <p:sp>
-        <p:nvSpPr>
-          <p:cNvPr id="8" name="Text 6"/>
-          <p:cNvSpPr txBox="1"/>
-          <p:nvPr/>
-        </p:nvSpPr>
-        <p:spPr>
-          <a:xfrm>
-            <a:off x="3291840" y="1828800"/>
-            <a:ext cx="2468880" cy="731520"/>
+              <a:t>Consulta 3 · platos más vendidos</a:t>
+            </a:r>
+            <a:endParaRPr lang="en-US" sz="1100" dirty="0"/>
+          </a:p>
+        </p:txBody>
+      </p:sp>
+      <p:pic>
+        <p:nvPicPr>
+          <p:cNvPr id="10" name="Image 3" descr="/home/m4ik_1/Documentos/cloudddd/entregables/capturas-athena/vista-1.png">    </p:cNvPr>
+          <p:cNvPicPr>
+            <a:picLocks noChangeAspect="1"/>
+          </p:cNvPicPr>
+          <p:nvPr/>
+        </p:nvPicPr>
+        <p:blipFill>
+          <a:blip r:embed="rId4"/>
+          <a:stretch>
+            <a:fillRect/>
+          </a:stretch>
+        </p:blipFill>
+        <p:spPr>
+          <a:xfrm>
+            <a:off x="4709160" y="3207258"/>
+            <a:ext cx="2743200" cy="1543050"/>
+          </a:xfrm>
+          <a:prstGeom prst="rect">
+            <a:avLst/>
+          </a:prstGeom>
+          <a:effectLst>
+            <a:outerShdw sx="100000" sy="100000" kx="0" ky="0" algn="bl" rotWithShape="0" blurRad="101600" dist="25400" dir="5400000">
+              <a:srgbClr val="000000">
+                <a:alpha val="15000"/>
+              </a:srgbClr>
+            </a:outerShdw>
+          </a:effectLst>
+        </p:spPr>
+      </p:pic>
+      <p:sp>
+        <p:nvSpPr>
+          <p:cNvPr id="11" name="Text 5"/>
+          <p:cNvSpPr txBox="1"/>
+          <p:nvPr/>
+        </p:nvSpPr>
+        <p:spPr>
+          <a:xfrm>
+            <a:off x="4709160" y="4796028"/>
+            <a:ext cx="2743200" cy="256032"/>
           </a:xfrm>
           <a:prstGeom prst="rect">
             <a:avLst/>
@@ -6095,112 +6281,7 @@
               <a:buNone/>
             </a:pPr>
             <a:r>
-              <a:rPr lang="en-US" sz="1800" dirty="0">
-                <a:solidFill>
-                  <a:srgbClr val="5F6B7A"/>
-                </a:solidFill>
-                <a:latin typeface="Calibri" pitchFamily="34" charset="0"/>
-                <a:ea typeface="Calibri" pitchFamily="34" charset="-122"/>
-                <a:cs typeface="Calibri" pitchFamily="34" charset="-120"/>
-              </a:rPr>
-              <a:t>4.2 MB · 0.84 s</a:t>
-            </a:r>
-            <a:endParaRPr lang="en-US" sz="1800" dirty="0"/>
-          </a:p>
-        </p:txBody>
-      </p:sp>
-      <p:sp>
-        <p:nvSpPr>
-          <p:cNvPr id="9" name="Text 7"/>
-          <p:cNvSpPr txBox="1"/>
-          <p:nvPr/>
-        </p:nvSpPr>
-        <p:spPr>
-          <a:xfrm>
-            <a:off x="6035040" y="1828800"/>
-            <a:ext cx="2651760" cy="731520"/>
-          </a:xfrm>
-          <a:prstGeom prst="rect">
-            <a:avLst/>
-          </a:prstGeom>
-          <a:noFill/>
-          <a:ln/>
-        </p:spPr>
-        <p:txBody>
-          <a:bodyPr wrap="square" lIns="0" tIns="0" rIns="0" bIns="0" rtlCol="0" anchor="ctr"/>
-          <a:lstStyle/>
-          <a:p>
-            <a:pPr indent="0" marL="0">
-              <a:buNone/>
-            </a:pPr>
-            <a:r>
-              <a:rPr lang="en-US" sz="2000" b="1" dirty="0">
-                <a:solidFill>
-                  <a:srgbClr val="ED7100"/>
-                </a:solidFill>
-                <a:latin typeface="Calibri" pitchFamily="34" charset="0"/>
-                <a:ea typeface="Calibri" pitchFamily="34" charset="-122"/>
-                <a:cs typeface="Calibri" pitchFamily="34" charset="-120"/>
-              </a:rPr>
-              <a:t>4 KB · 60 ms</a:t>
-            </a:r>
-            <a:endParaRPr lang="en-US" sz="2000" dirty="0"/>
-          </a:p>
-        </p:txBody>
-      </p:sp>
-      <p:sp>
-        <p:nvSpPr>
-          <p:cNvPr id="10" name="Shape 8"/>
-          <p:cNvSpPr/>
-          <p:nvPr/>
-        </p:nvSpPr>
-        <p:spPr>
-          <a:xfrm>
-            <a:off x="457200" y="2697480"/>
-            <a:ext cx="8229600" cy="731520"/>
-          </a:xfrm>
-          <a:prstGeom prst="roundRect">
-            <a:avLst>
-              <a:gd name="adj" fmla="val 10000"/>
-            </a:avLst>
-          </a:prstGeom>
-          <a:solidFill>
-            <a:srgbClr val="F2F4F7"/>
-          </a:solidFill>
-          <a:ln w="9525">
-            <a:solidFill>
-              <a:srgbClr val="E1E5EA"/>
-            </a:solidFill>
-            <a:prstDash val="solid"/>
-          </a:ln>
-        </p:spPr>
-      </p:sp>
-      <p:sp>
-        <p:nvSpPr>
-          <p:cNvPr id="11" name="Text 9"/>
-          <p:cNvSpPr txBox="1"/>
-          <p:nvPr/>
-        </p:nvSpPr>
-        <p:spPr>
-          <a:xfrm>
-            <a:off x="640080" y="2697480"/>
-            <a:ext cx="2560320" cy="731520"/>
-          </a:xfrm>
-          <a:prstGeom prst="rect">
-            <a:avLst/>
-          </a:prstGeom>
-          <a:noFill/>
-          <a:ln/>
-        </p:spPr>
-        <p:txBody>
-          <a:bodyPr wrap="square" lIns="0" tIns="0" rIns="0" bIns="0" rtlCol="0" anchor="ctr"/>
-          <a:lstStyle/>
-          <a:p>
-            <a:pPr indent="0" marL="0">
-              <a:buNone/>
-            </a:pPr>
-            <a:r>
-              <a:rPr lang="en-US" sz="1500" b="1" dirty="0">
+              <a:rPr lang="en-US" sz="1100" b="1" dirty="0">
                 <a:solidFill>
                   <a:srgbClr val="232F3E"/>
                 </a:solidFill>
@@ -6208,268 +6289,7 @@
                 <a:ea typeface="Calibri" pitchFamily="34" charset="-122"/>
                 <a:cs typeface="Calibri" pitchFamily="34" charset="-120"/>
               </a:rPr>
-              <a:t>Usuarios (MS1)</a:t>
-            </a:r>
-            <a:endParaRPr lang="en-US" sz="1500" dirty="0"/>
-          </a:p>
-        </p:txBody>
-      </p:sp>
-      <p:sp>
-        <p:nvSpPr>
-          <p:cNvPr id="12" name="Text 10"/>
-          <p:cNvSpPr txBox="1"/>
-          <p:nvPr/>
-        </p:nvSpPr>
-        <p:spPr>
-          <a:xfrm>
-            <a:off x="3291840" y="2697480"/>
-            <a:ext cx="2468880" cy="731520"/>
-          </a:xfrm>
-          <a:prstGeom prst="rect">
-            <a:avLst/>
-          </a:prstGeom>
-          <a:noFill/>
-          <a:ln/>
-        </p:spPr>
-        <p:txBody>
-          <a:bodyPr wrap="square" lIns="0" tIns="0" rIns="0" bIns="0" rtlCol="0" anchor="ctr"/>
-          <a:lstStyle/>
-          <a:p>
-            <a:pPr indent="0" marL="0">
-              <a:buNone/>
-            </a:pPr>
-            <a:r>
-              <a:rPr lang="en-US" sz="1800" dirty="0">
-                <a:solidFill>
-                  <a:srgbClr val="5F6B7A"/>
-                </a:solidFill>
-                <a:latin typeface="Calibri" pitchFamily="34" charset="0"/>
-                <a:ea typeface="Calibri" pitchFamily="34" charset="-122"/>
-                <a:cs typeface="Calibri" pitchFamily="34" charset="-120"/>
-              </a:rPr>
-              <a:t>6.6 MB · 2.3 s</a:t>
-            </a:r>
-            <a:endParaRPr lang="en-US" sz="1800" dirty="0"/>
-          </a:p>
-        </p:txBody>
-      </p:sp>
-      <p:sp>
-        <p:nvSpPr>
-          <p:cNvPr id="13" name="Text 11"/>
-          <p:cNvSpPr txBox="1"/>
-          <p:nvPr/>
-        </p:nvSpPr>
-        <p:spPr>
-          <a:xfrm>
-            <a:off x="6035040" y="2697480"/>
-            <a:ext cx="2651760" cy="731520"/>
-          </a:xfrm>
-          <a:prstGeom prst="rect">
-            <a:avLst/>
-          </a:prstGeom>
-          <a:noFill/>
-          <a:ln/>
-        </p:spPr>
-        <p:txBody>
-          <a:bodyPr wrap="square" lIns="0" tIns="0" rIns="0" bIns="0" rtlCol="0" anchor="ctr"/>
-          <a:lstStyle/>
-          <a:p>
-            <a:pPr indent="0" marL="0">
-              <a:buNone/>
-            </a:pPr>
-            <a:r>
-              <a:rPr lang="en-US" sz="2000" b="1" dirty="0">
-                <a:solidFill>
-                  <a:srgbClr val="ED7100"/>
-                </a:solidFill>
-                <a:latin typeface="Calibri" pitchFamily="34" charset="0"/>
-                <a:ea typeface="Calibri" pitchFamily="34" charset="-122"/>
-                <a:cs typeface="Calibri" pitchFamily="34" charset="-120"/>
-              </a:rPr>
-              <a:t>página: 14 ms</a:t>
-            </a:r>
-            <a:endParaRPr lang="en-US" sz="2000" dirty="0"/>
-          </a:p>
-        </p:txBody>
-      </p:sp>
-      <p:sp>
-        <p:nvSpPr>
-          <p:cNvPr id="14" name="Shape 12"/>
-          <p:cNvSpPr/>
-          <p:nvPr/>
-        </p:nvSpPr>
-        <p:spPr>
-          <a:xfrm>
-            <a:off x="457200" y="3566160"/>
-            <a:ext cx="8229600" cy="731520"/>
-          </a:xfrm>
-          <a:prstGeom prst="roundRect">
-            <a:avLst>
-              <a:gd name="adj" fmla="val 10000"/>
-            </a:avLst>
-          </a:prstGeom>
-          <a:solidFill>
-            <a:srgbClr val="F2F4F7"/>
-          </a:solidFill>
-          <a:ln w="9525">
-            <a:solidFill>
-              <a:srgbClr val="E1E5EA"/>
-            </a:solidFill>
-            <a:prstDash val="solid"/>
-          </a:ln>
-        </p:spPr>
-      </p:sp>
-      <p:sp>
-        <p:nvSpPr>
-          <p:cNvPr id="15" name="Text 13"/>
-          <p:cNvSpPr txBox="1"/>
-          <p:nvPr/>
-        </p:nvSpPr>
-        <p:spPr>
-          <a:xfrm>
-            <a:off x="640080" y="3566160"/>
-            <a:ext cx="2560320" cy="731520"/>
-          </a:xfrm>
-          <a:prstGeom prst="rect">
-            <a:avLst/>
-          </a:prstGeom>
-          <a:noFill/>
-          <a:ln/>
-        </p:spPr>
-        <p:txBody>
-          <a:bodyPr wrap="square" lIns="0" tIns="0" rIns="0" bIns="0" rtlCol="0" anchor="ctr"/>
-          <a:lstStyle/>
-          <a:p>
-            <a:pPr indent="0" marL="0">
-              <a:buNone/>
-            </a:pPr>
-            <a:r>
-              <a:rPr lang="en-US" sz="1500" b="1" dirty="0">
-                <a:solidFill>
-                  <a:srgbClr val="232F3E"/>
-                </a:solidFill>
-                <a:latin typeface="Calibri" pitchFamily="34" charset="0"/>
-                <a:ea typeface="Calibri" pitchFamily="34" charset="-122"/>
-                <a:cs typeface="Calibri" pitchFamily="34" charset="-120"/>
-              </a:rPr>
-              <a:t>Restaurantes (20,000)</a:t>
-            </a:r>
-            <a:endParaRPr lang="en-US" sz="1500" dirty="0"/>
-          </a:p>
-        </p:txBody>
-      </p:sp>
-      <p:sp>
-        <p:nvSpPr>
-          <p:cNvPr id="16" name="Text 14"/>
-          <p:cNvSpPr txBox="1"/>
-          <p:nvPr/>
-        </p:nvSpPr>
-        <p:spPr>
-          <a:xfrm>
-            <a:off x="3291840" y="3566160"/>
-            <a:ext cx="2468880" cy="731520"/>
-          </a:xfrm>
-          <a:prstGeom prst="rect">
-            <a:avLst/>
-          </a:prstGeom>
-          <a:noFill/>
-          <a:ln/>
-        </p:spPr>
-        <p:txBody>
-          <a:bodyPr wrap="square" lIns="0" tIns="0" rIns="0" bIns="0" rtlCol="0" anchor="ctr"/>
-          <a:lstStyle/>
-          <a:p>
-            <a:pPr indent="0" marL="0">
-              <a:buNone/>
-            </a:pPr>
-            <a:r>
-              <a:rPr lang="en-US" sz="1800" dirty="0">
-                <a:solidFill>
-                  <a:srgbClr val="5F6B7A"/>
-                </a:solidFill>
-                <a:latin typeface="Calibri" pitchFamily="34" charset="0"/>
-                <a:ea typeface="Calibri" pitchFamily="34" charset="-122"/>
-                <a:cs typeface="Calibri" pitchFamily="34" charset="-120"/>
-              </a:rPr>
-              <a:t>21 MB · 1.0 s</a:t>
-            </a:r>
-            <a:endParaRPr lang="en-US" sz="1800" dirty="0"/>
-          </a:p>
-        </p:txBody>
-      </p:sp>
-      <p:sp>
-        <p:nvSpPr>
-          <p:cNvPr id="17" name="Text 15"/>
-          <p:cNvSpPr txBox="1"/>
-          <p:nvPr/>
-        </p:nvSpPr>
-        <p:spPr>
-          <a:xfrm>
-            <a:off x="6035040" y="3566160"/>
-            <a:ext cx="2651760" cy="731520"/>
-          </a:xfrm>
-          <a:prstGeom prst="rect">
-            <a:avLst/>
-          </a:prstGeom>
-          <a:noFill/>
-          <a:ln/>
-        </p:spPr>
-        <p:txBody>
-          <a:bodyPr wrap="square" lIns="0" tIns="0" rIns="0" bIns="0" rtlCol="0" anchor="ctr"/>
-          <a:lstStyle/>
-          <a:p>
-            <a:pPr indent="0" marL="0">
-              <a:buNone/>
-            </a:pPr>
-            <a:r>
-              <a:rPr lang="en-US" sz="2000" b="1" dirty="0">
-                <a:solidFill>
-                  <a:srgbClr val="ED7100"/>
-                </a:solidFill>
-                <a:latin typeface="Calibri" pitchFamily="34" charset="0"/>
-                <a:ea typeface="Calibri" pitchFamily="34" charset="-122"/>
-                <a:cs typeface="Calibri" pitchFamily="34" charset="-120"/>
-              </a:rPr>
-              <a:t>página de 12: 14 ms</a:t>
-            </a:r>
-            <a:endParaRPr lang="en-US" sz="2000" dirty="0"/>
-          </a:p>
-        </p:txBody>
-      </p:sp>
-      <p:sp>
-        <p:nvSpPr>
-          <p:cNvPr id="18" name="Text 16"/>
-          <p:cNvSpPr txBox="1"/>
-          <p:nvPr/>
-        </p:nvSpPr>
-        <p:spPr>
-          <a:xfrm>
-            <a:off x="457200" y="4526280"/>
-            <a:ext cx="8229600" cy="320040"/>
-          </a:xfrm>
-          <a:prstGeom prst="rect">
-            <a:avLst/>
-          </a:prstGeom>
-          <a:noFill/>
-          <a:ln/>
-        </p:spPr>
-        <p:txBody>
-          <a:bodyPr wrap="square" lIns="0" tIns="0" rIns="0" bIns="0" rtlCol="0" anchor="ctr"/>
-          <a:lstStyle/>
-          <a:p>
-            <a:pPr indent="0" marL="0">
-              <a:buNone/>
-            </a:pPr>
-            <a:r>
-              <a:rPr lang="en-US" sz="1100" i="1" dirty="0">
-                <a:solidFill>
-                  <a:srgbClr val="5F6B7A"/>
-                </a:solidFill>
-                <a:latin typeface="Calibri" pitchFamily="34" charset="0"/>
-                <a:ea typeface="Calibri" pitchFamily="34" charset="-122"/>
-                <a:cs typeface="Calibri" pitchFamily="34" charset="-120"/>
-              </a:rPr>
-              <a:t>page_size vale 20 por defecto y se limita a 100 · total en la cabecera X-Total-Count · mediciones locales con unos 40 mil pedidos</a:t>
+              <a:t>Vista v_resumen_ventas_restaurante</a:t>
             </a:r>
             <a:endParaRPr lang="en-US" sz="1100" dirty="0"/>
           </a:p>
@@ -6540,7 +6360,7 @@
                 <a:ea typeface="Calibri" pitchFamily="34" charset="-122"/>
                 <a:cs typeface="Calibri" pitchFamily="34" charset="-120"/>
               </a:rPr>
-              <a:t>Pruebas y validación</a:t>
+              <a:t>Paginado opcional: de megabytes a kilobytes</a:t>
             </a:r>
             <a:endParaRPr lang="en-US" sz="2800" dirty="0"/>
           </a:p>
@@ -6554,8 +6374,8 @@
         </p:nvSpPr>
         <p:spPr>
           <a:xfrm>
-            <a:off x="548640" y="1188720"/>
-            <a:ext cx="2560320" cy="685800"/>
+            <a:off x="457200" y="786384"/>
+            <a:ext cx="8229600" cy="320040"/>
           </a:xfrm>
           <a:prstGeom prst="rect">
             <a:avLst/>
@@ -6571,7 +6391,85 @@
               <a:buNone/>
             </a:pPr>
             <a:r>
-              <a:rPr lang="en-US" sz="3800" b="1" dirty="0">
+              <a:rPr lang="en-US" sz="1400" dirty="0">
+                <a:solidFill>
+                  <a:srgbClr val="5F6B7A"/>
+                </a:solidFill>
+                <a:latin typeface="Calibri" pitchFamily="34" charset="0"/>
+                <a:ea typeface="Calibri" pitchFamily="34" charset="-122"/>
+                <a:cs typeface="Calibri" pitchFamily="34" charset="-120"/>
+              </a:rPr>
+              <a:t>Misma ruta, dos modos: sin parámetros devuelve todo; con ?page= y ?page_size= devuelve una página</a:t>
+            </a:r>
+            <a:endParaRPr lang="en-US" sz="1400" dirty="0"/>
+          </a:p>
+        </p:txBody>
+      </p:sp>
+      <p:sp>
+        <p:nvSpPr>
+          <p:cNvPr id="4" name="Text 2"/>
+          <p:cNvSpPr txBox="1"/>
+          <p:nvPr/>
+        </p:nvSpPr>
+        <p:spPr>
+          <a:xfrm>
+            <a:off x="3291840" y="1417320"/>
+            <a:ext cx="2468880" cy="320040"/>
+          </a:xfrm>
+          <a:prstGeom prst="rect">
+            <a:avLst/>
+          </a:prstGeom>
+          <a:noFill/>
+          <a:ln/>
+        </p:spPr>
+        <p:txBody>
+          <a:bodyPr wrap="square" lIns="0" tIns="0" rIns="0" bIns="0" rtlCol="0" anchor="ctr"/>
+          <a:lstStyle/>
+          <a:p>
+            <a:pPr indent="0" marL="0">
+              <a:buNone/>
+            </a:pPr>
+            <a:r>
+              <a:rPr lang="en-US" sz="1300" b="1" dirty="0">
+                <a:solidFill>
+                  <a:srgbClr val="5F6B7A"/>
+                </a:solidFill>
+                <a:latin typeface="Calibri" pitchFamily="34" charset="0"/>
+                <a:ea typeface="Calibri" pitchFamily="34" charset="-122"/>
+                <a:cs typeface="Calibri" pitchFamily="34" charset="-120"/>
+              </a:rPr>
+              <a:t>Sin paginar</a:t>
+            </a:r>
+            <a:endParaRPr lang="en-US" sz="1300" dirty="0"/>
+          </a:p>
+        </p:txBody>
+      </p:sp>
+      <p:sp>
+        <p:nvSpPr>
+          <p:cNvPr id="5" name="Text 3"/>
+          <p:cNvSpPr txBox="1"/>
+          <p:nvPr/>
+        </p:nvSpPr>
+        <p:spPr>
+          <a:xfrm>
+            <a:off x="6035040" y="1417320"/>
+            <a:ext cx="2651760" cy="320040"/>
+          </a:xfrm>
+          <a:prstGeom prst="rect">
+            <a:avLst/>
+          </a:prstGeom>
+          <a:noFill/>
+          <a:ln/>
+        </p:spPr>
+        <p:txBody>
+          <a:bodyPr wrap="square" lIns="0" tIns="0" rIns="0" bIns="0" rtlCol="0" anchor="ctr"/>
+          <a:lstStyle/>
+          <a:p>
+            <a:pPr indent="0" marL="0">
+              <a:buNone/>
+            </a:pPr>
+            <a:r>
+              <a:rPr lang="en-US" sz="1300" b="1" dirty="0">
                 <a:solidFill>
                   <a:srgbClr val="ED7100"/>
                 </a:solidFill>
@@ -6579,221 +6477,26 @@
                 <a:ea typeface="Calibri" pitchFamily="34" charset="-122"/>
                 <a:cs typeface="Calibri" pitchFamily="34" charset="-120"/>
               </a:rPr>
-              <a:t>72</a:t>
-            </a:r>
-            <a:endParaRPr lang="en-US" sz="3800" dirty="0"/>
-          </a:p>
-        </p:txBody>
-      </p:sp>
-      <p:sp>
-        <p:nvSpPr>
-          <p:cNvPr id="4" name="Text 2"/>
-          <p:cNvSpPr txBox="1"/>
-          <p:nvPr/>
-        </p:nvSpPr>
-        <p:spPr>
-          <a:xfrm>
-            <a:off x="548640" y="1874520"/>
-            <a:ext cx="2560320" cy="457200"/>
-          </a:xfrm>
-          <a:prstGeom prst="rect">
-            <a:avLst/>
-          </a:prstGeom>
-          <a:noFill/>
-          <a:ln/>
-        </p:spPr>
-        <p:txBody>
-          <a:bodyPr wrap="square" lIns="0" tIns="0" rIns="0" bIns="0" rtlCol="0" anchor="t"/>
-          <a:lstStyle/>
-          <a:p>
-            <a:pPr indent="0" marL="0">
-              <a:buNone/>
-            </a:pPr>
-            <a:r>
-              <a:rPr lang="en-US" sz="1200" dirty="0">
-                <a:solidFill>
-                  <a:srgbClr val="5F6B7A"/>
-                </a:solidFill>
-                <a:latin typeface="Calibri" pitchFamily="34" charset="0"/>
-                <a:ea typeface="Calibri" pitchFamily="34" charset="-122"/>
-                <a:cs typeface="Calibri" pitchFamily="34" charset="-120"/>
-              </a:rPr>
-              <a:t>requests de Postman/Newman · 66 aserciones · 0 fallos</a:t>
-            </a:r>
-            <a:endParaRPr lang="en-US" sz="1200" dirty="0"/>
-          </a:p>
-        </p:txBody>
-      </p:sp>
-      <p:sp>
-        <p:nvSpPr>
-          <p:cNvPr id="5" name="Text 3"/>
-          <p:cNvSpPr txBox="1"/>
-          <p:nvPr/>
-        </p:nvSpPr>
-        <p:spPr>
-          <a:xfrm>
-            <a:off x="3291840" y="1188720"/>
-            <a:ext cx="2560320" cy="685800"/>
-          </a:xfrm>
-          <a:prstGeom prst="rect">
-            <a:avLst/>
-          </a:prstGeom>
-          <a:noFill/>
-          <a:ln/>
-        </p:spPr>
-        <p:txBody>
-          <a:bodyPr wrap="square" lIns="0" tIns="0" rIns="0" bIns="0" rtlCol="0" anchor="ctr"/>
-          <a:lstStyle/>
-          <a:p>
-            <a:pPr indent="0" marL="0">
-              <a:buNone/>
-            </a:pPr>
-            <a:r>
-              <a:rPr lang="en-US" sz="3800" b="1" dirty="0">
-                <a:solidFill>
-                  <a:srgbClr val="ED7100"/>
-                </a:solidFill>
-                <a:latin typeface="Calibri" pitchFamily="34" charset="0"/>
-                <a:ea typeface="Calibri" pitchFamily="34" charset="-122"/>
-                <a:cs typeface="Calibri" pitchFamily="34" charset="-120"/>
-              </a:rPr>
-              <a:t>3 roles</a:t>
-            </a:r>
-            <a:endParaRPr lang="en-US" sz="3800" dirty="0"/>
-          </a:p>
-        </p:txBody>
-      </p:sp>
-      <p:sp>
-        <p:nvSpPr>
-          <p:cNvPr id="6" name="Text 4"/>
-          <p:cNvSpPr txBox="1"/>
-          <p:nvPr/>
-        </p:nvSpPr>
-        <p:spPr>
-          <a:xfrm>
-            <a:off x="3291840" y="1874520"/>
-            <a:ext cx="2560320" cy="457200"/>
-          </a:xfrm>
-          <a:prstGeom prst="rect">
-            <a:avLst/>
-          </a:prstGeom>
-          <a:noFill/>
-          <a:ln/>
-        </p:spPr>
-        <p:txBody>
-          <a:bodyPr wrap="square" lIns="0" tIns="0" rIns="0" bIns="0" rtlCol="0" anchor="t"/>
-          <a:lstStyle/>
-          <a:p>
-            <a:pPr indent="0" marL="0">
-              <a:buNone/>
-            </a:pPr>
-            <a:r>
-              <a:rPr lang="en-US" sz="1200" dirty="0">
-                <a:solidFill>
-                  <a:srgbClr val="5F6B7A"/>
-                </a:solidFill>
-                <a:latin typeface="Calibri" pitchFamily="34" charset="0"/>
-                <a:ea typeface="Calibri" pitchFamily="34" charset="-122"/>
-                <a:cs typeface="Calibri" pitchFamily="34" charset="-120"/>
-              </a:rPr>
-              <a:t>recorridos completos con Playwright sobre la URL de Amplify</a:t>
-            </a:r>
-            <a:endParaRPr lang="en-US" sz="1200" dirty="0"/>
-          </a:p>
-        </p:txBody>
-      </p:sp>
-      <p:sp>
-        <p:nvSpPr>
-          <p:cNvPr id="7" name="Text 5"/>
-          <p:cNvSpPr txBox="1"/>
-          <p:nvPr/>
-        </p:nvSpPr>
-        <p:spPr>
-          <a:xfrm>
-            <a:off x="6035040" y="1188720"/>
-            <a:ext cx="2743200" cy="685800"/>
-          </a:xfrm>
-          <a:prstGeom prst="rect">
-            <a:avLst/>
-          </a:prstGeom>
-          <a:noFill/>
-          <a:ln/>
-        </p:spPr>
-        <p:txBody>
-          <a:bodyPr wrap="square" lIns="0" tIns="0" rIns="0" bIns="0" rtlCol="0" anchor="ctr"/>
-          <a:lstStyle/>
-          <a:p>
-            <a:pPr indent="0" marL="0">
-              <a:buNone/>
-            </a:pPr>
-            <a:r>
-              <a:rPr lang="en-US" sz="3800" b="1" dirty="0">
-                <a:solidFill>
-                  <a:srgbClr val="ED7100"/>
-                </a:solidFill>
-                <a:latin typeface="Calibri" pitchFamily="34" charset="0"/>
-                <a:ea typeface="Calibri" pitchFamily="34" charset="-122"/>
-                <a:cs typeface="Calibri" pitchFamily="34" charset="-120"/>
-              </a:rPr>
-              <a:t>30 / 30</a:t>
-            </a:r>
-            <a:endParaRPr lang="en-US" sz="3800" dirty="0"/>
-          </a:p>
-        </p:txBody>
-      </p:sp>
-      <p:sp>
-        <p:nvSpPr>
-          <p:cNvPr id="8" name="Text 6"/>
-          <p:cNvSpPr txBox="1"/>
-          <p:nvPr/>
-        </p:nvSpPr>
-        <p:spPr>
-          <a:xfrm>
-            <a:off x="6035040" y="1874520"/>
-            <a:ext cx="2743200" cy="457200"/>
-          </a:xfrm>
-          <a:prstGeom prst="rect">
-            <a:avLst/>
-          </a:prstGeom>
-          <a:noFill/>
-          <a:ln/>
-        </p:spPr>
-        <p:txBody>
-          <a:bodyPr wrap="square" lIns="0" tIns="0" rIns="0" bIns="0" rtlCol="0" anchor="t"/>
-          <a:lstStyle/>
-          <a:p>
-            <a:pPr indent="0" marL="0">
-              <a:buNone/>
-            </a:pPr>
-            <a:r>
-              <a:rPr lang="en-US" sz="1200" dirty="0">
-                <a:solidFill>
-                  <a:srgbClr val="5F6B7A"/>
-                </a:solidFill>
-                <a:latin typeface="Calibri" pitchFamily="34" charset="0"/>
-                <a:ea typeface="Calibri" pitchFamily="34" charset="-122"/>
-                <a:cs typeface="Calibri" pitchFamily="34" charset="-120"/>
-              </a:rPr>
-              <a:t>respuestas 200 con una de las 2 VMs caída</a:t>
-            </a:r>
-            <a:endParaRPr lang="en-US" sz="1200" dirty="0"/>
-          </a:p>
-        </p:txBody>
-      </p:sp>
-      <p:sp>
-        <p:nvSpPr>
-          <p:cNvPr id="9" name="Shape 7"/>
+              <a:t>Paginado</a:t>
+            </a:r>
+            <a:endParaRPr lang="en-US" sz="1300" dirty="0"/>
+          </a:p>
+        </p:txBody>
+      </p:sp>
+      <p:sp>
+        <p:nvSpPr>
+          <p:cNvPr id="6" name="Shape 4"/>
           <p:cNvSpPr/>
           <p:nvPr/>
         </p:nvSpPr>
         <p:spPr>
           <a:xfrm>
-            <a:off x="457200" y="2743200"/>
-            <a:ext cx="8229600" cy="1737360"/>
+            <a:off x="457200" y="1828800"/>
+            <a:ext cx="8229600" cy="731520"/>
           </a:xfrm>
           <a:prstGeom prst="roundRect">
             <a:avLst>
-              <a:gd name="adj" fmla="val 4211"/>
+              <a:gd name="adj" fmla="val 10000"/>
             </a:avLst>
           </a:prstGeom>
           <a:solidFill>
@@ -6809,14 +6512,14 @@
       </p:sp>
       <p:sp>
         <p:nvSpPr>
-          <p:cNvPr id="10" name="Text 8"/>
-          <p:cNvSpPr txBox="1"/>
-          <p:nvPr/>
-        </p:nvSpPr>
-        <p:spPr>
-          <a:xfrm>
-            <a:off x="685800" y="2834640"/>
-            <a:ext cx="7772400" cy="1554480"/>
+          <p:cNvPr id="7" name="Text 5"/>
+          <p:cNvSpPr txBox="1"/>
+          <p:nvPr/>
+        </p:nvSpPr>
+        <p:spPr>
+          <a:xfrm>
+            <a:off x="640080" y="1828800"/>
+            <a:ext cx="2560320" cy="731520"/>
           </a:xfrm>
           <a:prstGeom prst="rect">
             <a:avLst/>
@@ -6828,88 +6531,426 @@
           <a:bodyPr wrap="square" lIns="0" tIns="0" rIns="0" bIns="0" rtlCol="0" anchor="ctr"/>
           <a:lstStyle/>
           <a:p>
-            <a:pPr marL="342900" indent="-342900">
-              <a:spcAft>
-                <a:spcPts val="600"/>
-              </a:spcAft>
-              <a:buSzPct val="100000"/>
-              <a:buChar char="•"/>
-            </a:pPr>
-            <a:r>
-              <a:rPr lang="en-US" sz="1400" dirty="0">
-                <a:solidFill>
-                  <a:srgbClr val="1F2933"/>
-                </a:solidFill>
-                <a:latin typeface="Calibri" pitchFamily="34" charset="0"/>
-                <a:ea typeface="Calibri" pitchFamily="34" charset="-122"/>
-                <a:cs typeface="Calibri" pitchFamily="34" charset="-120"/>
-              </a:rPr>
-              <a:t>Casos de error incluidos: 400, 401 y 422; con y sin paginado</a:t>
-            </a:r>
-            <a:endParaRPr lang="en-US" sz="1400" dirty="0"/>
-          </a:p>
-          <a:p>
-            <a:pPr marL="342900" indent="-342900">
-              <a:spcAft>
-                <a:spcPts val="600"/>
-              </a:spcAft>
-              <a:buSzPct val="100000"/>
-              <a:buChar char="•"/>
-            </a:pPr>
-            <a:r>
-              <a:rPr lang="en-US" sz="1400" dirty="0">
-                <a:solidFill>
-                  <a:srgbClr val="1F2933"/>
-                </a:solidFill>
-                <a:latin typeface="Calibri" pitchFamily="34" charset="0"/>
-                <a:ea typeface="Calibri" pitchFamily="34" charset="-122"/>
-                <a:cs typeface="Calibri" pitchFamily="34" charset="-120"/>
-              </a:rPr>
-              <a:t>Conteos de Athena coinciden con las bases de datos</a:t>
-            </a:r>
-            <a:endParaRPr lang="en-US" sz="1400" dirty="0"/>
-          </a:p>
-          <a:p>
-            <a:pPr marL="342900" indent="-342900">
-              <a:spcAft>
-                <a:spcPts val="600"/>
-              </a:spcAft>
-              <a:buSzPct val="100000"/>
-              <a:buChar char="•"/>
-            </a:pPr>
-            <a:r>
-              <a:rPr lang="en-US" sz="1400" dirty="0">
-                <a:solidFill>
-                  <a:srgbClr val="1F2933"/>
-                </a:solidFill>
-                <a:latin typeface="Calibri" pitchFamily="34" charset="0"/>
-                <a:ea typeface="Calibri" pitchFamily="34" charset="-122"/>
-                <a:cs typeface="Calibri" pitchFamily="34" charset="-120"/>
-              </a:rPr>
-              <a:t>Puertos 22, 3306, 5432 y 27017 cerrados a internet</a:t>
-            </a:r>
-            <a:endParaRPr lang="en-US" sz="1400" dirty="0"/>
-          </a:p>
-          <a:p>
-            <a:pPr marL="342900" indent="-342900">
-              <a:spcAft>
-                <a:spcPts val="600"/>
-              </a:spcAft>
-              <a:buSzPct val="100000"/>
-              <a:buChar char="•"/>
-            </a:pPr>
-            <a:r>
-              <a:rPr lang="en-US" sz="1400" dirty="0">
-                <a:solidFill>
-                  <a:srgbClr val="1F2933"/>
-                </a:solidFill>
-                <a:latin typeface="Calibri" pitchFamily="34" charset="0"/>
-                <a:ea typeface="Calibri" pitchFamily="34" charset="-122"/>
-                <a:cs typeface="Calibri" pitchFamily="34" charset="-120"/>
-              </a:rPr>
-              <a:t>Swagger UI verificado en los 5 servicios a través del API Gateway</a:t>
-            </a:r>
-            <a:endParaRPr lang="en-US" sz="1400" dirty="0"/>
+            <a:pPr indent="0" marL="0">
+              <a:buNone/>
+            </a:pPr>
+            <a:r>
+              <a:rPr lang="en-US" sz="1500" b="1" dirty="0">
+                <a:solidFill>
+                  <a:srgbClr val="232F3E"/>
+                </a:solidFill>
+                <a:latin typeface="Calibri" pitchFamily="34" charset="0"/>
+                <a:ea typeface="Calibri" pitchFamily="34" charset="-122"/>
+                <a:cs typeface="Calibri" pitchFamily="34" charset="-120"/>
+              </a:rPr>
+              <a:t>Dashboard admin</a:t>
+            </a:r>
+            <a:endParaRPr lang="en-US" sz="1500" dirty="0"/>
+          </a:p>
+        </p:txBody>
+      </p:sp>
+      <p:sp>
+        <p:nvSpPr>
+          <p:cNvPr id="8" name="Text 6"/>
+          <p:cNvSpPr txBox="1"/>
+          <p:nvPr/>
+        </p:nvSpPr>
+        <p:spPr>
+          <a:xfrm>
+            <a:off x="3291840" y="1828800"/>
+            <a:ext cx="2468880" cy="731520"/>
+          </a:xfrm>
+          <a:prstGeom prst="rect">
+            <a:avLst/>
+          </a:prstGeom>
+          <a:noFill/>
+          <a:ln/>
+        </p:spPr>
+        <p:txBody>
+          <a:bodyPr wrap="square" lIns="0" tIns="0" rIns="0" bIns="0" rtlCol="0" anchor="ctr"/>
+          <a:lstStyle/>
+          <a:p>
+            <a:pPr indent="0" marL="0">
+              <a:buNone/>
+            </a:pPr>
+            <a:r>
+              <a:rPr lang="en-US" sz="1800" dirty="0">
+                <a:solidFill>
+                  <a:srgbClr val="5F6B7A"/>
+                </a:solidFill>
+                <a:latin typeface="Calibri" pitchFamily="34" charset="0"/>
+                <a:ea typeface="Calibri" pitchFamily="34" charset="-122"/>
+                <a:cs typeface="Calibri" pitchFamily="34" charset="-120"/>
+              </a:rPr>
+              <a:t>4.2 MB · 0.84 s</a:t>
+            </a:r>
+            <a:endParaRPr lang="en-US" sz="1800" dirty="0"/>
+          </a:p>
+        </p:txBody>
+      </p:sp>
+      <p:sp>
+        <p:nvSpPr>
+          <p:cNvPr id="9" name="Text 7"/>
+          <p:cNvSpPr txBox="1"/>
+          <p:nvPr/>
+        </p:nvSpPr>
+        <p:spPr>
+          <a:xfrm>
+            <a:off x="6035040" y="1828800"/>
+            <a:ext cx="2651760" cy="731520"/>
+          </a:xfrm>
+          <a:prstGeom prst="rect">
+            <a:avLst/>
+          </a:prstGeom>
+          <a:noFill/>
+          <a:ln/>
+        </p:spPr>
+        <p:txBody>
+          <a:bodyPr wrap="square" lIns="0" tIns="0" rIns="0" bIns="0" rtlCol="0" anchor="ctr"/>
+          <a:lstStyle/>
+          <a:p>
+            <a:pPr indent="0" marL="0">
+              <a:buNone/>
+            </a:pPr>
+            <a:r>
+              <a:rPr lang="en-US" sz="2000" b="1" dirty="0">
+                <a:solidFill>
+                  <a:srgbClr val="ED7100"/>
+                </a:solidFill>
+                <a:latin typeface="Calibri" pitchFamily="34" charset="0"/>
+                <a:ea typeface="Calibri" pitchFamily="34" charset="-122"/>
+                <a:cs typeface="Calibri" pitchFamily="34" charset="-120"/>
+              </a:rPr>
+              <a:t>4 KB · 60 ms</a:t>
+            </a:r>
+            <a:endParaRPr lang="en-US" sz="2000" dirty="0"/>
+          </a:p>
+        </p:txBody>
+      </p:sp>
+      <p:sp>
+        <p:nvSpPr>
+          <p:cNvPr id="10" name="Shape 8"/>
+          <p:cNvSpPr/>
+          <p:nvPr/>
+        </p:nvSpPr>
+        <p:spPr>
+          <a:xfrm>
+            <a:off x="457200" y="2697480"/>
+            <a:ext cx="8229600" cy="731520"/>
+          </a:xfrm>
+          <a:prstGeom prst="roundRect">
+            <a:avLst>
+              <a:gd name="adj" fmla="val 10000"/>
+            </a:avLst>
+          </a:prstGeom>
+          <a:solidFill>
+            <a:srgbClr val="F2F4F7"/>
+          </a:solidFill>
+          <a:ln w="9525">
+            <a:solidFill>
+              <a:srgbClr val="E1E5EA"/>
+            </a:solidFill>
+            <a:prstDash val="solid"/>
+          </a:ln>
+        </p:spPr>
+      </p:sp>
+      <p:sp>
+        <p:nvSpPr>
+          <p:cNvPr id="11" name="Text 9"/>
+          <p:cNvSpPr txBox="1"/>
+          <p:nvPr/>
+        </p:nvSpPr>
+        <p:spPr>
+          <a:xfrm>
+            <a:off x="640080" y="2697480"/>
+            <a:ext cx="2560320" cy="731520"/>
+          </a:xfrm>
+          <a:prstGeom prst="rect">
+            <a:avLst/>
+          </a:prstGeom>
+          <a:noFill/>
+          <a:ln/>
+        </p:spPr>
+        <p:txBody>
+          <a:bodyPr wrap="square" lIns="0" tIns="0" rIns="0" bIns="0" rtlCol="0" anchor="ctr"/>
+          <a:lstStyle/>
+          <a:p>
+            <a:pPr indent="0" marL="0">
+              <a:buNone/>
+            </a:pPr>
+            <a:r>
+              <a:rPr lang="en-US" sz="1500" b="1" dirty="0">
+                <a:solidFill>
+                  <a:srgbClr val="232F3E"/>
+                </a:solidFill>
+                <a:latin typeface="Calibri" pitchFamily="34" charset="0"/>
+                <a:ea typeface="Calibri" pitchFamily="34" charset="-122"/>
+                <a:cs typeface="Calibri" pitchFamily="34" charset="-120"/>
+              </a:rPr>
+              <a:t>Usuarios (MS1)</a:t>
+            </a:r>
+            <a:endParaRPr lang="en-US" sz="1500" dirty="0"/>
+          </a:p>
+        </p:txBody>
+      </p:sp>
+      <p:sp>
+        <p:nvSpPr>
+          <p:cNvPr id="12" name="Text 10"/>
+          <p:cNvSpPr txBox="1"/>
+          <p:nvPr/>
+        </p:nvSpPr>
+        <p:spPr>
+          <a:xfrm>
+            <a:off x="3291840" y="2697480"/>
+            <a:ext cx="2468880" cy="731520"/>
+          </a:xfrm>
+          <a:prstGeom prst="rect">
+            <a:avLst/>
+          </a:prstGeom>
+          <a:noFill/>
+          <a:ln/>
+        </p:spPr>
+        <p:txBody>
+          <a:bodyPr wrap="square" lIns="0" tIns="0" rIns="0" bIns="0" rtlCol="0" anchor="ctr"/>
+          <a:lstStyle/>
+          <a:p>
+            <a:pPr indent="0" marL="0">
+              <a:buNone/>
+            </a:pPr>
+            <a:r>
+              <a:rPr lang="en-US" sz="1800" dirty="0">
+                <a:solidFill>
+                  <a:srgbClr val="5F6B7A"/>
+                </a:solidFill>
+                <a:latin typeface="Calibri" pitchFamily="34" charset="0"/>
+                <a:ea typeface="Calibri" pitchFamily="34" charset="-122"/>
+                <a:cs typeface="Calibri" pitchFamily="34" charset="-120"/>
+              </a:rPr>
+              <a:t>6.6 MB · 2.3 s</a:t>
+            </a:r>
+            <a:endParaRPr lang="en-US" sz="1800" dirty="0"/>
+          </a:p>
+        </p:txBody>
+      </p:sp>
+      <p:sp>
+        <p:nvSpPr>
+          <p:cNvPr id="13" name="Text 11"/>
+          <p:cNvSpPr txBox="1"/>
+          <p:nvPr/>
+        </p:nvSpPr>
+        <p:spPr>
+          <a:xfrm>
+            <a:off x="6035040" y="2697480"/>
+            <a:ext cx="2651760" cy="731520"/>
+          </a:xfrm>
+          <a:prstGeom prst="rect">
+            <a:avLst/>
+          </a:prstGeom>
+          <a:noFill/>
+          <a:ln/>
+        </p:spPr>
+        <p:txBody>
+          <a:bodyPr wrap="square" lIns="0" tIns="0" rIns="0" bIns="0" rtlCol="0" anchor="ctr"/>
+          <a:lstStyle/>
+          <a:p>
+            <a:pPr indent="0" marL="0">
+              <a:buNone/>
+            </a:pPr>
+            <a:r>
+              <a:rPr lang="en-US" sz="2000" b="1" dirty="0">
+                <a:solidFill>
+                  <a:srgbClr val="ED7100"/>
+                </a:solidFill>
+                <a:latin typeface="Calibri" pitchFamily="34" charset="0"/>
+                <a:ea typeface="Calibri" pitchFamily="34" charset="-122"/>
+                <a:cs typeface="Calibri" pitchFamily="34" charset="-120"/>
+              </a:rPr>
+              <a:t>página: 14 ms</a:t>
+            </a:r>
+            <a:endParaRPr lang="en-US" sz="2000" dirty="0"/>
+          </a:p>
+        </p:txBody>
+      </p:sp>
+      <p:sp>
+        <p:nvSpPr>
+          <p:cNvPr id="14" name="Shape 12"/>
+          <p:cNvSpPr/>
+          <p:nvPr/>
+        </p:nvSpPr>
+        <p:spPr>
+          <a:xfrm>
+            <a:off x="457200" y="3566160"/>
+            <a:ext cx="8229600" cy="731520"/>
+          </a:xfrm>
+          <a:prstGeom prst="roundRect">
+            <a:avLst>
+              <a:gd name="adj" fmla="val 10000"/>
+            </a:avLst>
+          </a:prstGeom>
+          <a:solidFill>
+            <a:srgbClr val="F2F4F7"/>
+          </a:solidFill>
+          <a:ln w="9525">
+            <a:solidFill>
+              <a:srgbClr val="E1E5EA"/>
+            </a:solidFill>
+            <a:prstDash val="solid"/>
+          </a:ln>
+        </p:spPr>
+      </p:sp>
+      <p:sp>
+        <p:nvSpPr>
+          <p:cNvPr id="15" name="Text 13"/>
+          <p:cNvSpPr txBox="1"/>
+          <p:nvPr/>
+        </p:nvSpPr>
+        <p:spPr>
+          <a:xfrm>
+            <a:off x="640080" y="3566160"/>
+            <a:ext cx="2560320" cy="731520"/>
+          </a:xfrm>
+          <a:prstGeom prst="rect">
+            <a:avLst/>
+          </a:prstGeom>
+          <a:noFill/>
+          <a:ln/>
+        </p:spPr>
+        <p:txBody>
+          <a:bodyPr wrap="square" lIns="0" tIns="0" rIns="0" bIns="0" rtlCol="0" anchor="ctr"/>
+          <a:lstStyle/>
+          <a:p>
+            <a:pPr indent="0" marL="0">
+              <a:buNone/>
+            </a:pPr>
+            <a:r>
+              <a:rPr lang="en-US" sz="1500" b="1" dirty="0">
+                <a:solidFill>
+                  <a:srgbClr val="232F3E"/>
+                </a:solidFill>
+                <a:latin typeface="Calibri" pitchFamily="34" charset="0"/>
+                <a:ea typeface="Calibri" pitchFamily="34" charset="-122"/>
+                <a:cs typeface="Calibri" pitchFamily="34" charset="-120"/>
+              </a:rPr>
+              <a:t>Restaurantes (20,000)</a:t>
+            </a:r>
+            <a:endParaRPr lang="en-US" sz="1500" dirty="0"/>
+          </a:p>
+        </p:txBody>
+      </p:sp>
+      <p:sp>
+        <p:nvSpPr>
+          <p:cNvPr id="16" name="Text 14"/>
+          <p:cNvSpPr txBox="1"/>
+          <p:nvPr/>
+        </p:nvSpPr>
+        <p:spPr>
+          <a:xfrm>
+            <a:off x="3291840" y="3566160"/>
+            <a:ext cx="2468880" cy="731520"/>
+          </a:xfrm>
+          <a:prstGeom prst="rect">
+            <a:avLst/>
+          </a:prstGeom>
+          <a:noFill/>
+          <a:ln/>
+        </p:spPr>
+        <p:txBody>
+          <a:bodyPr wrap="square" lIns="0" tIns="0" rIns="0" bIns="0" rtlCol="0" anchor="ctr"/>
+          <a:lstStyle/>
+          <a:p>
+            <a:pPr indent="0" marL="0">
+              <a:buNone/>
+            </a:pPr>
+            <a:r>
+              <a:rPr lang="en-US" sz="1800" dirty="0">
+                <a:solidFill>
+                  <a:srgbClr val="5F6B7A"/>
+                </a:solidFill>
+                <a:latin typeface="Calibri" pitchFamily="34" charset="0"/>
+                <a:ea typeface="Calibri" pitchFamily="34" charset="-122"/>
+                <a:cs typeface="Calibri" pitchFamily="34" charset="-120"/>
+              </a:rPr>
+              <a:t>21 MB · 1.0 s</a:t>
+            </a:r>
+            <a:endParaRPr lang="en-US" sz="1800" dirty="0"/>
+          </a:p>
+        </p:txBody>
+      </p:sp>
+      <p:sp>
+        <p:nvSpPr>
+          <p:cNvPr id="17" name="Text 15"/>
+          <p:cNvSpPr txBox="1"/>
+          <p:nvPr/>
+        </p:nvSpPr>
+        <p:spPr>
+          <a:xfrm>
+            <a:off x="6035040" y="3566160"/>
+            <a:ext cx="2651760" cy="731520"/>
+          </a:xfrm>
+          <a:prstGeom prst="rect">
+            <a:avLst/>
+          </a:prstGeom>
+          <a:noFill/>
+          <a:ln/>
+        </p:spPr>
+        <p:txBody>
+          <a:bodyPr wrap="square" lIns="0" tIns="0" rIns="0" bIns="0" rtlCol="0" anchor="ctr"/>
+          <a:lstStyle/>
+          <a:p>
+            <a:pPr indent="0" marL="0">
+              <a:buNone/>
+            </a:pPr>
+            <a:r>
+              <a:rPr lang="en-US" sz="2000" b="1" dirty="0">
+                <a:solidFill>
+                  <a:srgbClr val="ED7100"/>
+                </a:solidFill>
+                <a:latin typeface="Calibri" pitchFamily="34" charset="0"/>
+                <a:ea typeface="Calibri" pitchFamily="34" charset="-122"/>
+                <a:cs typeface="Calibri" pitchFamily="34" charset="-120"/>
+              </a:rPr>
+              <a:t>página de 12: 14 ms</a:t>
+            </a:r>
+            <a:endParaRPr lang="en-US" sz="2000" dirty="0"/>
+          </a:p>
+        </p:txBody>
+      </p:sp>
+      <p:sp>
+        <p:nvSpPr>
+          <p:cNvPr id="18" name="Text 16"/>
+          <p:cNvSpPr txBox="1"/>
+          <p:nvPr/>
+        </p:nvSpPr>
+        <p:spPr>
+          <a:xfrm>
+            <a:off x="457200" y="4526280"/>
+            <a:ext cx="8229600" cy="320040"/>
+          </a:xfrm>
+          <a:prstGeom prst="rect">
+            <a:avLst/>
+          </a:prstGeom>
+          <a:noFill/>
+          <a:ln/>
+        </p:spPr>
+        <p:txBody>
+          <a:bodyPr wrap="square" lIns="0" tIns="0" rIns="0" bIns="0" rtlCol="0" anchor="ctr"/>
+          <a:lstStyle/>
+          <a:p>
+            <a:pPr indent="0" marL="0">
+              <a:buNone/>
+            </a:pPr>
+            <a:r>
+              <a:rPr lang="en-US" sz="1100" i="1" dirty="0">
+                <a:solidFill>
+                  <a:srgbClr val="5F6B7A"/>
+                </a:solidFill>
+                <a:latin typeface="Calibri" pitchFamily="34" charset="0"/>
+                <a:ea typeface="Calibri" pitchFamily="34" charset="-122"/>
+                <a:cs typeface="Calibri" pitchFamily="34" charset="-120"/>
+              </a:rPr>
+              <a:t>page_size vale 20 por defecto y se limita a 100 · total en la cabecera X-Total-Count · mediciones locales con unos 40 mil pedidos</a:t>
+            </a:r>
+            <a:endParaRPr lang="en-US" sz="1100" dirty="0"/>
           </a:p>
         </p:txBody>
       </p:sp>
@@ -6978,7 +7019,7 @@
                 <a:ea typeface="Calibri" pitchFamily="34" charset="-122"/>
                 <a:cs typeface="Calibri" pitchFamily="34" charset="-120"/>
               </a:rPr>
-              <a:t>Limitaciones y próximos pasos</a:t>
+              <a:t>Pruebas y validación</a:t>
             </a:r>
             <a:endParaRPr lang="en-US" sz="2800" dirty="0"/>
           </a:p>
@@ -6986,18 +7027,252 @@
       </p:sp>
       <p:sp>
         <p:nvSpPr>
-          <p:cNvPr id="3" name="Shape 1"/>
+          <p:cNvPr id="3" name="Text 1"/>
+          <p:cNvSpPr txBox="1"/>
+          <p:nvPr/>
+        </p:nvSpPr>
+        <p:spPr>
+          <a:xfrm>
+            <a:off x="548640" y="1188720"/>
+            <a:ext cx="2560320" cy="685800"/>
+          </a:xfrm>
+          <a:prstGeom prst="rect">
+            <a:avLst/>
+          </a:prstGeom>
+          <a:noFill/>
+          <a:ln/>
+        </p:spPr>
+        <p:txBody>
+          <a:bodyPr wrap="square" lIns="0" tIns="0" rIns="0" bIns="0" rtlCol="0" anchor="ctr"/>
+          <a:lstStyle/>
+          <a:p>
+            <a:pPr indent="0" marL="0">
+              <a:buNone/>
+            </a:pPr>
+            <a:r>
+              <a:rPr lang="en-US" sz="3800" b="1" dirty="0">
+                <a:solidFill>
+                  <a:srgbClr val="ED7100"/>
+                </a:solidFill>
+                <a:latin typeface="Calibri" pitchFamily="34" charset="0"/>
+                <a:ea typeface="Calibri" pitchFamily="34" charset="-122"/>
+                <a:cs typeface="Calibri" pitchFamily="34" charset="-120"/>
+              </a:rPr>
+              <a:t>72</a:t>
+            </a:r>
+            <a:endParaRPr lang="en-US" sz="3800" dirty="0"/>
+          </a:p>
+        </p:txBody>
+      </p:sp>
+      <p:sp>
+        <p:nvSpPr>
+          <p:cNvPr id="4" name="Text 2"/>
+          <p:cNvSpPr txBox="1"/>
+          <p:nvPr/>
+        </p:nvSpPr>
+        <p:spPr>
+          <a:xfrm>
+            <a:off x="548640" y="1874520"/>
+            <a:ext cx="2560320" cy="457200"/>
+          </a:xfrm>
+          <a:prstGeom prst="rect">
+            <a:avLst/>
+          </a:prstGeom>
+          <a:noFill/>
+          <a:ln/>
+        </p:spPr>
+        <p:txBody>
+          <a:bodyPr wrap="square" lIns="0" tIns="0" rIns="0" bIns="0" rtlCol="0" anchor="t"/>
+          <a:lstStyle/>
+          <a:p>
+            <a:pPr indent="0" marL="0">
+              <a:buNone/>
+            </a:pPr>
+            <a:r>
+              <a:rPr lang="en-US" sz="1200" dirty="0">
+                <a:solidFill>
+                  <a:srgbClr val="5F6B7A"/>
+                </a:solidFill>
+                <a:latin typeface="Calibri" pitchFamily="34" charset="0"/>
+                <a:ea typeface="Calibri" pitchFamily="34" charset="-122"/>
+                <a:cs typeface="Calibri" pitchFamily="34" charset="-120"/>
+              </a:rPr>
+              <a:t>requests de Postman/Newman · 66 aserciones · 0 fallos</a:t>
+            </a:r>
+            <a:endParaRPr lang="en-US" sz="1200" dirty="0"/>
+          </a:p>
+        </p:txBody>
+      </p:sp>
+      <p:sp>
+        <p:nvSpPr>
+          <p:cNvPr id="5" name="Text 3"/>
+          <p:cNvSpPr txBox="1"/>
+          <p:nvPr/>
+        </p:nvSpPr>
+        <p:spPr>
+          <a:xfrm>
+            <a:off x="3291840" y="1188720"/>
+            <a:ext cx="2560320" cy="685800"/>
+          </a:xfrm>
+          <a:prstGeom prst="rect">
+            <a:avLst/>
+          </a:prstGeom>
+          <a:noFill/>
+          <a:ln/>
+        </p:spPr>
+        <p:txBody>
+          <a:bodyPr wrap="square" lIns="0" tIns="0" rIns="0" bIns="0" rtlCol="0" anchor="ctr"/>
+          <a:lstStyle/>
+          <a:p>
+            <a:pPr indent="0" marL="0">
+              <a:buNone/>
+            </a:pPr>
+            <a:r>
+              <a:rPr lang="en-US" sz="3800" b="1" dirty="0">
+                <a:solidFill>
+                  <a:srgbClr val="ED7100"/>
+                </a:solidFill>
+                <a:latin typeface="Calibri" pitchFamily="34" charset="0"/>
+                <a:ea typeface="Calibri" pitchFamily="34" charset="-122"/>
+                <a:cs typeface="Calibri" pitchFamily="34" charset="-120"/>
+              </a:rPr>
+              <a:t>3 roles</a:t>
+            </a:r>
+            <a:endParaRPr lang="en-US" sz="3800" dirty="0"/>
+          </a:p>
+        </p:txBody>
+      </p:sp>
+      <p:sp>
+        <p:nvSpPr>
+          <p:cNvPr id="6" name="Text 4"/>
+          <p:cNvSpPr txBox="1"/>
+          <p:nvPr/>
+        </p:nvSpPr>
+        <p:spPr>
+          <a:xfrm>
+            <a:off x="3291840" y="1874520"/>
+            <a:ext cx="2560320" cy="457200"/>
+          </a:xfrm>
+          <a:prstGeom prst="rect">
+            <a:avLst/>
+          </a:prstGeom>
+          <a:noFill/>
+          <a:ln/>
+        </p:spPr>
+        <p:txBody>
+          <a:bodyPr wrap="square" lIns="0" tIns="0" rIns="0" bIns="0" rtlCol="0" anchor="t"/>
+          <a:lstStyle/>
+          <a:p>
+            <a:pPr indent="0" marL="0">
+              <a:buNone/>
+            </a:pPr>
+            <a:r>
+              <a:rPr lang="en-US" sz="1200" dirty="0">
+                <a:solidFill>
+                  <a:srgbClr val="5F6B7A"/>
+                </a:solidFill>
+                <a:latin typeface="Calibri" pitchFamily="34" charset="0"/>
+                <a:ea typeface="Calibri" pitchFamily="34" charset="-122"/>
+                <a:cs typeface="Calibri" pitchFamily="34" charset="-120"/>
+              </a:rPr>
+              <a:t>recorridos completos con Playwright sobre la URL de Amplify</a:t>
+            </a:r>
+            <a:endParaRPr lang="en-US" sz="1200" dirty="0"/>
+          </a:p>
+        </p:txBody>
+      </p:sp>
+      <p:sp>
+        <p:nvSpPr>
+          <p:cNvPr id="7" name="Text 5"/>
+          <p:cNvSpPr txBox="1"/>
+          <p:nvPr/>
+        </p:nvSpPr>
+        <p:spPr>
+          <a:xfrm>
+            <a:off x="6035040" y="1188720"/>
+            <a:ext cx="2743200" cy="685800"/>
+          </a:xfrm>
+          <a:prstGeom prst="rect">
+            <a:avLst/>
+          </a:prstGeom>
+          <a:noFill/>
+          <a:ln/>
+        </p:spPr>
+        <p:txBody>
+          <a:bodyPr wrap="square" lIns="0" tIns="0" rIns="0" bIns="0" rtlCol="0" anchor="ctr"/>
+          <a:lstStyle/>
+          <a:p>
+            <a:pPr indent="0" marL="0">
+              <a:buNone/>
+            </a:pPr>
+            <a:r>
+              <a:rPr lang="en-US" sz="3800" b="1" dirty="0">
+                <a:solidFill>
+                  <a:srgbClr val="ED7100"/>
+                </a:solidFill>
+                <a:latin typeface="Calibri" pitchFamily="34" charset="0"/>
+                <a:ea typeface="Calibri" pitchFamily="34" charset="-122"/>
+                <a:cs typeface="Calibri" pitchFamily="34" charset="-120"/>
+              </a:rPr>
+              <a:t>30 / 30</a:t>
+            </a:r>
+            <a:endParaRPr lang="en-US" sz="3800" dirty="0"/>
+          </a:p>
+        </p:txBody>
+      </p:sp>
+      <p:sp>
+        <p:nvSpPr>
+          <p:cNvPr id="8" name="Text 6"/>
+          <p:cNvSpPr txBox="1"/>
+          <p:nvPr/>
+        </p:nvSpPr>
+        <p:spPr>
+          <a:xfrm>
+            <a:off x="6035040" y="1874520"/>
+            <a:ext cx="2743200" cy="457200"/>
+          </a:xfrm>
+          <a:prstGeom prst="rect">
+            <a:avLst/>
+          </a:prstGeom>
+          <a:noFill/>
+          <a:ln/>
+        </p:spPr>
+        <p:txBody>
+          <a:bodyPr wrap="square" lIns="0" tIns="0" rIns="0" bIns="0" rtlCol="0" anchor="t"/>
+          <a:lstStyle/>
+          <a:p>
+            <a:pPr indent="0" marL="0">
+              <a:buNone/>
+            </a:pPr>
+            <a:r>
+              <a:rPr lang="en-US" sz="1200" dirty="0">
+                <a:solidFill>
+                  <a:srgbClr val="5F6B7A"/>
+                </a:solidFill>
+                <a:latin typeface="Calibri" pitchFamily="34" charset="0"/>
+                <a:ea typeface="Calibri" pitchFamily="34" charset="-122"/>
+                <a:cs typeface="Calibri" pitchFamily="34" charset="-120"/>
+              </a:rPr>
+              <a:t>respuestas 200 con una de las 2 VMs caída</a:t>
+            </a:r>
+            <a:endParaRPr lang="en-US" sz="1200" dirty="0"/>
+          </a:p>
+        </p:txBody>
+      </p:sp>
+      <p:sp>
+        <p:nvSpPr>
+          <p:cNvPr id="9" name="Shape 7"/>
           <p:cNvSpPr/>
           <p:nvPr/>
         </p:nvSpPr>
         <p:spPr>
           <a:xfrm>
-            <a:off x="457200" y="1188720"/>
-            <a:ext cx="4023360" cy="3108960"/>
+            <a:off x="457200" y="2743200"/>
+            <a:ext cx="8229600" cy="1737360"/>
           </a:xfrm>
           <a:prstGeom prst="roundRect">
             <a:avLst>
-              <a:gd name="adj" fmla="val 2353"/>
+              <a:gd name="adj" fmla="val 4211"/>
             </a:avLst>
           </a:prstGeom>
           <a:solidFill>
@@ -7013,14 +7288,14 @@
       </p:sp>
       <p:sp>
         <p:nvSpPr>
-          <p:cNvPr id="4" name="Text 2"/>
-          <p:cNvSpPr txBox="1"/>
-          <p:nvPr/>
-        </p:nvSpPr>
-        <p:spPr>
-          <a:xfrm>
-            <a:off x="640080" y="1298448"/>
-            <a:ext cx="3657600" cy="365760"/>
+          <p:cNvPr id="10" name="Text 8"/>
+          <p:cNvSpPr txBox="1"/>
+          <p:nvPr/>
+        </p:nvSpPr>
+        <p:spPr>
+          <a:xfrm>
+            <a:off x="685800" y="2834640"/>
+            <a:ext cx="7772400" cy="1554480"/>
           </a:xfrm>
           <a:prstGeom prst="rect">
             <a:avLst/>
@@ -7030,56 +7305,17 @@
         </p:spPr>
         <p:txBody>
           <a:bodyPr wrap="square" lIns="0" tIns="0" rIns="0" bIns="0" rtlCol="0" anchor="ctr"/>
-          <a:lstStyle/>
-          <a:p>
-            <a:pPr indent="0" marL="0">
-              <a:buNone/>
-            </a:pPr>
-            <a:r>
-              <a:rPr lang="en-US" sz="1600" b="1" dirty="0">
-                <a:solidFill>
-                  <a:srgbClr val="ED7100"/>
-                </a:solidFill>
-                <a:latin typeface="Calibri" pitchFamily="34" charset="0"/>
-                <a:ea typeface="Calibri" pitchFamily="34" charset="-122"/>
-                <a:cs typeface="Calibri" pitchFamily="34" charset="-120"/>
-              </a:rPr>
-              <a:t>Limitaciones actuales</a:t>
-            </a:r>
-            <a:endParaRPr lang="en-US" sz="1600" dirty="0"/>
-          </a:p>
-        </p:txBody>
-      </p:sp>
-      <p:sp>
-        <p:nvSpPr>
-          <p:cNvPr id="5" name="Text 3"/>
-          <p:cNvSpPr txBox="1"/>
-          <p:nvPr/>
-        </p:nvSpPr>
-        <p:spPr>
-          <a:xfrm>
-            <a:off x="640080" y="1783080"/>
-            <a:ext cx="3657600" cy="2377440"/>
-          </a:xfrm>
-          <a:prstGeom prst="rect">
-            <a:avLst/>
-          </a:prstGeom>
-          <a:noFill/>
-          <a:ln/>
-        </p:spPr>
-        <p:txBody>
-          <a:bodyPr wrap="square" lIns="0" tIns="0" rIns="0" bIns="0" rtlCol="0" anchor="t"/>
           <a:lstStyle/>
           <a:p>
             <a:pPr marL="342900" indent="-342900">
               <a:spcAft>
-                <a:spcPts val="800"/>
+                <a:spcPts val="600"/>
               </a:spcAft>
               <a:buSzPct val="100000"/>
               <a:buChar char="•"/>
             </a:pPr>
             <a:r>
-              <a:rPr lang="en-US" sz="1300" dirty="0">
+              <a:rPr lang="en-US" sz="1400" dirty="0">
                 <a:solidFill>
                   <a:srgbClr val="1F2933"/>
                 </a:solidFill>
@@ -7087,20 +7323,20 @@
                 <a:ea typeface="Calibri" pitchFamily="34" charset="-122"/>
                 <a:cs typeface="Calibri" pitchFamily="34" charset="-120"/>
               </a:rPr>
-              <a:t>Las VMs aún aceptan el puerto 80 desde internet: cerrar y dejar solo el ALB</a:t>
-            </a:r>
-            <a:endParaRPr lang="en-US" sz="1300" dirty="0"/>
+              <a:t>Casos de error incluidos: 400, 401 y 422; con y sin paginado</a:t>
+            </a:r>
+            <a:endParaRPr lang="en-US" sz="1400" dirty="0"/>
           </a:p>
           <a:p>
             <a:pPr marL="342900" indent="-342900">
               <a:spcAft>
-                <a:spcPts val="800"/>
+                <a:spcPts val="600"/>
               </a:spcAft>
               <a:buSzPct val="100000"/>
               <a:buChar char="•"/>
             </a:pPr>
             <a:r>
-              <a:rPr lang="en-US" sz="1300" dirty="0">
+              <a:rPr lang="en-US" sz="1400" dirty="0">
                 <a:solidFill>
                   <a:srgbClr val="1F2933"/>
                 </a:solidFill>
@@ -7108,20 +7344,20 @@
                 <a:ea typeface="Calibri" pitchFamily="34" charset="-122"/>
                 <a:cs typeface="Calibri" pitchFamily="34" charset="-120"/>
               </a:rPr>
-              <a:t>Amplify se despliega con un zip: conectar GitHub para CI/CD</a:t>
-            </a:r>
-            <a:endParaRPr lang="en-US" sz="1300" dirty="0"/>
+              <a:t>Conteos de Athena coinciden con las bases de datos</a:t>
+            </a:r>
+            <a:endParaRPr lang="en-US" sz="1400" dirty="0"/>
           </a:p>
           <a:p>
             <a:pPr marL="342900" indent="-342900">
               <a:spcAft>
-                <a:spcPts val="800"/>
+                <a:spcPts val="600"/>
               </a:spcAft>
               <a:buSzPct val="100000"/>
               <a:buChar char="•"/>
             </a:pPr>
             <a:r>
-              <a:rPr lang="en-US" sz="1300" dirty="0">
+              <a:rPr lang="en-US" sz="1400" dirty="0">
                 <a:solidFill>
                   <a:srgbClr val="1F2933"/>
                 </a:solidFill>
@@ -7129,108 +7365,20 @@
                 <a:ea typeface="Calibri" pitchFamily="34" charset="-122"/>
                 <a:cs typeface="Calibri" pitchFamily="34" charset="-120"/>
               </a:rPr>
-              <a:t>VMs t2.micro (1 GB) con swap: subir a t3.small</a:t>
-            </a:r>
-            <a:endParaRPr lang="en-US" sz="1300" dirty="0"/>
-          </a:p>
-        </p:txBody>
-      </p:sp>
-      <p:sp>
-        <p:nvSpPr>
-          <p:cNvPr id="6" name="Shape 4"/>
-          <p:cNvSpPr/>
-          <p:nvPr/>
-        </p:nvSpPr>
-        <p:spPr>
-          <a:xfrm>
-            <a:off x="4663440" y="1188720"/>
-            <a:ext cx="4023360" cy="3108960"/>
-          </a:xfrm>
-          <a:prstGeom prst="roundRect">
-            <a:avLst>
-              <a:gd name="adj" fmla="val 2353"/>
-            </a:avLst>
-          </a:prstGeom>
-          <a:solidFill>
-            <a:srgbClr val="F2F4F7"/>
-          </a:solidFill>
-          <a:ln w="9525">
-            <a:solidFill>
-              <a:srgbClr val="E1E5EA"/>
-            </a:solidFill>
-            <a:prstDash val="solid"/>
-          </a:ln>
-        </p:spPr>
-      </p:sp>
-      <p:sp>
-        <p:nvSpPr>
-          <p:cNvPr id="7" name="Text 5"/>
-          <p:cNvSpPr txBox="1"/>
-          <p:nvPr/>
-        </p:nvSpPr>
-        <p:spPr>
-          <a:xfrm>
-            <a:off x="4846320" y="1298448"/>
-            <a:ext cx="3657600" cy="365760"/>
-          </a:xfrm>
-          <a:prstGeom prst="rect">
-            <a:avLst/>
-          </a:prstGeom>
-          <a:noFill/>
-          <a:ln/>
-        </p:spPr>
-        <p:txBody>
-          <a:bodyPr wrap="square" lIns="0" tIns="0" rIns="0" bIns="0" rtlCol="0" anchor="ctr"/>
-          <a:lstStyle/>
-          <a:p>
-            <a:pPr indent="0" marL="0">
-              <a:buNone/>
-            </a:pPr>
-            <a:r>
-              <a:rPr lang="en-US" sz="1600" b="1" dirty="0">
-                <a:solidFill>
-                  <a:srgbClr val="ED7100"/>
-                </a:solidFill>
-                <a:latin typeface="Calibri" pitchFamily="34" charset="0"/>
-                <a:ea typeface="Calibri" pitchFamily="34" charset="-122"/>
-                <a:cs typeface="Calibri" pitchFamily="34" charset="-120"/>
-              </a:rPr>
-              <a:t>Próximos pasos</a:t>
-            </a:r>
-            <a:endParaRPr lang="en-US" sz="1600" dirty="0"/>
-          </a:p>
-        </p:txBody>
-      </p:sp>
-      <p:sp>
-        <p:nvSpPr>
-          <p:cNvPr id="8" name="Text 6"/>
-          <p:cNvSpPr txBox="1"/>
-          <p:nvPr/>
-        </p:nvSpPr>
-        <p:spPr>
-          <a:xfrm>
-            <a:off x="4846320" y="1783080"/>
-            <a:ext cx="3657600" cy="2377440"/>
-          </a:xfrm>
-          <a:prstGeom prst="rect">
-            <a:avLst/>
-          </a:prstGeom>
-          <a:noFill/>
-          <a:ln/>
-        </p:spPr>
-        <p:txBody>
-          <a:bodyPr wrap="square" lIns="0" tIns="0" rIns="0" bIns="0" rtlCol="0" anchor="t"/>
-          <a:lstStyle/>
+              <a:t>Puertos 22, 3306, 5432 y 27017 cerrados a internet</a:t>
+            </a:r>
+            <a:endParaRPr lang="en-US" sz="1400" dirty="0"/>
+          </a:p>
           <a:p>
             <a:pPr marL="342900" indent="-342900">
               <a:spcAft>
-                <a:spcPts val="800"/>
+                <a:spcPts val="600"/>
               </a:spcAft>
               <a:buSzPct val="100000"/>
               <a:buChar char="•"/>
             </a:pPr>
             <a:r>
-              <a:rPr lang="en-US" sz="1300" dirty="0">
+              <a:rPr lang="en-US" sz="1400" dirty="0">
                 <a:solidFill>
                   <a:srgbClr val="1F2933"/>
                 </a:solidFill>
@@ -7238,51 +7386,9 @@
                 <a:ea typeface="Calibri" pitchFamily="34" charset="-122"/>
                 <a:cs typeface="Calibri" pitchFamily="34" charset="-120"/>
               </a:rPr>
-              <a:t>Derivar el usuario de las reseñas del token JWT</a:t>
-            </a:r>
-            <a:endParaRPr lang="en-US" sz="1300" dirty="0"/>
-          </a:p>
-          <a:p>
-            <a:pPr marL="342900" indent="-342900">
-              <a:spcAft>
-                <a:spcPts val="800"/>
-              </a:spcAft>
-              <a:buSzPct val="100000"/>
-              <a:buChar char="•"/>
-            </a:pPr>
-            <a:r>
-              <a:rPr lang="en-US" sz="1300" dirty="0">
-                <a:solidFill>
-                  <a:srgbClr val="1F2933"/>
-                </a:solidFill>
-                <a:latin typeface="Calibri" pitchFamily="34" charset="0"/>
-                <a:ea typeface="Calibri" pitchFamily="34" charset="-122"/>
-                <a:cs typeface="Calibri" pitchFamily="34" charset="-120"/>
-              </a:rPr>
-              <a:t>Programar la ingesta y el crawler (EventBridge)</a:t>
-            </a:r>
-            <a:endParaRPr lang="en-US" sz="1300" dirty="0"/>
-          </a:p>
-          <a:p>
-            <a:pPr marL="342900" indent="-342900">
-              <a:spcAft>
-                <a:spcPts val="800"/>
-              </a:spcAft>
-              <a:buSzPct val="100000"/>
-              <a:buChar char="•"/>
-            </a:pPr>
-            <a:r>
-              <a:rPr lang="en-US" sz="1300" dirty="0">
-                <a:solidFill>
-                  <a:srgbClr val="1F2933"/>
-                </a:solidFill>
-                <a:latin typeface="Calibri" pitchFamily="34" charset="0"/>
-                <a:ea typeface="Calibri" pitchFamily="34" charset="-122"/>
-                <a:cs typeface="Calibri" pitchFamily="34" charset="-120"/>
-              </a:rPr>
-              <a:t>Excluir password_hash del data lake</a:t>
-            </a:r>
-            <a:endParaRPr lang="en-US" sz="1300" dirty="0"/>
+              <a:t>Swagger UI verificado en los 5 servicios a través del API Gateway</a:t>
+            </a:r>
+            <a:endParaRPr lang="en-US" sz="1400" dirty="0"/>
           </a:p>
         </p:txBody>
       </p:sp>
@@ -7297,6 +7403,379 @@
 <file path=ppt/slides/slide16.xml><?xml version="1.0" encoding="utf-8"?>
 <p:sld xmlns:a="http://schemas.openxmlformats.org/drawingml/2006/main" xmlns:r="http://schemas.openxmlformats.org/officeDocument/2006/relationships" xmlns:p="http://schemas.openxmlformats.org/presentationml/2006/main">
   <p:cSld name="Slide 16">
+    <p:bg>
+      <p:bgPr>
+        <a:solidFill>
+          <a:srgbClr val="FFFFFF"/>
+        </a:solidFill>
+      </p:bgPr>
+    </p:bg>
+    <p:spTree>
+      <p:nvGrpSpPr>
+        <p:cNvPr id="1" name=""/>
+        <p:cNvGrpSpPr/>
+        <p:nvPr/>
+      </p:nvGrpSpPr>
+      <p:grpSpPr>
+        <a:xfrm>
+          <a:off x="0" y="0"/>
+          <a:ext cx="0" cy="0"/>
+          <a:chOff x="0" y="0"/>
+          <a:chExt cx="0" cy="0"/>
+        </a:xfrm>
+      </p:grpSpPr>
+      <p:sp>
+        <p:nvSpPr>
+          <p:cNvPr id="2" name="Text 0"/>
+          <p:cNvSpPr txBox="1"/>
+          <p:nvPr/>
+        </p:nvSpPr>
+        <p:spPr>
+          <a:xfrm>
+            <a:off x="457200" y="256032"/>
+            <a:ext cx="8229600" cy="548640"/>
+          </a:xfrm>
+          <a:prstGeom prst="rect">
+            <a:avLst/>
+          </a:prstGeom>
+          <a:noFill/>
+          <a:ln/>
+        </p:spPr>
+        <p:txBody>
+          <a:bodyPr wrap="square" lIns="0" tIns="0" rIns="0" bIns="0" rtlCol="0" anchor="ctr"/>
+          <a:lstStyle/>
+          <a:p>
+            <a:pPr indent="0" marL="0">
+              <a:buNone/>
+            </a:pPr>
+            <a:r>
+              <a:rPr lang="en-US" sz="2800" b="1" dirty="0">
+                <a:solidFill>
+                  <a:srgbClr val="232F3E"/>
+                </a:solidFill>
+                <a:latin typeface="Calibri" pitchFamily="34" charset="0"/>
+                <a:ea typeface="Calibri" pitchFamily="34" charset="-122"/>
+                <a:cs typeface="Calibri" pitchFamily="34" charset="-120"/>
+              </a:rPr>
+              <a:t>Limitaciones y próximos pasos</a:t>
+            </a:r>
+            <a:endParaRPr lang="en-US" sz="2800" dirty="0"/>
+          </a:p>
+        </p:txBody>
+      </p:sp>
+      <p:sp>
+        <p:nvSpPr>
+          <p:cNvPr id="3" name="Shape 1"/>
+          <p:cNvSpPr/>
+          <p:nvPr/>
+        </p:nvSpPr>
+        <p:spPr>
+          <a:xfrm>
+            <a:off x="457200" y="1188720"/>
+            <a:ext cx="4023360" cy="3108960"/>
+          </a:xfrm>
+          <a:prstGeom prst="roundRect">
+            <a:avLst>
+              <a:gd name="adj" fmla="val 2353"/>
+            </a:avLst>
+          </a:prstGeom>
+          <a:solidFill>
+            <a:srgbClr val="F2F4F7"/>
+          </a:solidFill>
+          <a:ln w="9525">
+            <a:solidFill>
+              <a:srgbClr val="E1E5EA"/>
+            </a:solidFill>
+            <a:prstDash val="solid"/>
+          </a:ln>
+        </p:spPr>
+      </p:sp>
+      <p:sp>
+        <p:nvSpPr>
+          <p:cNvPr id="4" name="Text 2"/>
+          <p:cNvSpPr txBox="1"/>
+          <p:nvPr/>
+        </p:nvSpPr>
+        <p:spPr>
+          <a:xfrm>
+            <a:off x="640080" y="1298448"/>
+            <a:ext cx="3657600" cy="365760"/>
+          </a:xfrm>
+          <a:prstGeom prst="rect">
+            <a:avLst/>
+          </a:prstGeom>
+          <a:noFill/>
+          <a:ln/>
+        </p:spPr>
+        <p:txBody>
+          <a:bodyPr wrap="square" lIns="0" tIns="0" rIns="0" bIns="0" rtlCol="0" anchor="ctr"/>
+          <a:lstStyle/>
+          <a:p>
+            <a:pPr indent="0" marL="0">
+              <a:buNone/>
+            </a:pPr>
+            <a:r>
+              <a:rPr lang="en-US" sz="1600" b="1" dirty="0">
+                <a:solidFill>
+                  <a:srgbClr val="ED7100"/>
+                </a:solidFill>
+                <a:latin typeface="Calibri" pitchFamily="34" charset="0"/>
+                <a:ea typeface="Calibri" pitchFamily="34" charset="-122"/>
+                <a:cs typeface="Calibri" pitchFamily="34" charset="-120"/>
+              </a:rPr>
+              <a:t>Limitaciones actuales</a:t>
+            </a:r>
+            <a:endParaRPr lang="en-US" sz="1600" dirty="0"/>
+          </a:p>
+        </p:txBody>
+      </p:sp>
+      <p:sp>
+        <p:nvSpPr>
+          <p:cNvPr id="5" name="Text 3"/>
+          <p:cNvSpPr txBox="1"/>
+          <p:nvPr/>
+        </p:nvSpPr>
+        <p:spPr>
+          <a:xfrm>
+            <a:off x="640080" y="1783080"/>
+            <a:ext cx="3657600" cy="2377440"/>
+          </a:xfrm>
+          <a:prstGeom prst="rect">
+            <a:avLst/>
+          </a:prstGeom>
+          <a:noFill/>
+          <a:ln/>
+        </p:spPr>
+        <p:txBody>
+          <a:bodyPr wrap="square" lIns="0" tIns="0" rIns="0" bIns="0" rtlCol="0" anchor="t"/>
+          <a:lstStyle/>
+          <a:p>
+            <a:pPr marL="342900" indent="-342900">
+              <a:spcAft>
+                <a:spcPts val="800"/>
+              </a:spcAft>
+              <a:buSzPct val="100000"/>
+              <a:buChar char="•"/>
+            </a:pPr>
+            <a:r>
+              <a:rPr lang="en-US" sz="1300" dirty="0">
+                <a:solidFill>
+                  <a:srgbClr val="1F2933"/>
+                </a:solidFill>
+                <a:latin typeface="Calibri" pitchFamily="34" charset="0"/>
+                <a:ea typeface="Calibri" pitchFamily="34" charset="-122"/>
+                <a:cs typeface="Calibri" pitchFamily="34" charset="-120"/>
+              </a:rPr>
+              <a:t>Las VMs aún aceptan el puerto 80 desde internet: cerrar y dejar solo el ALB</a:t>
+            </a:r>
+            <a:endParaRPr lang="en-US" sz="1300" dirty="0"/>
+          </a:p>
+          <a:p>
+            <a:pPr marL="342900" indent="-342900">
+              <a:spcAft>
+                <a:spcPts val="800"/>
+              </a:spcAft>
+              <a:buSzPct val="100000"/>
+              <a:buChar char="•"/>
+            </a:pPr>
+            <a:r>
+              <a:rPr lang="en-US" sz="1300" dirty="0">
+                <a:solidFill>
+                  <a:srgbClr val="1F2933"/>
+                </a:solidFill>
+                <a:latin typeface="Calibri" pitchFamily="34" charset="0"/>
+                <a:ea typeface="Calibri" pitchFamily="34" charset="-122"/>
+                <a:cs typeface="Calibri" pitchFamily="34" charset="-120"/>
+              </a:rPr>
+              <a:t>Amplify se despliega con un zip: conectar GitHub para CI/CD</a:t>
+            </a:r>
+            <a:endParaRPr lang="en-US" sz="1300" dirty="0"/>
+          </a:p>
+          <a:p>
+            <a:pPr marL="342900" indent="-342900">
+              <a:spcAft>
+                <a:spcPts val="800"/>
+              </a:spcAft>
+              <a:buSzPct val="100000"/>
+              <a:buChar char="•"/>
+            </a:pPr>
+            <a:r>
+              <a:rPr lang="en-US" sz="1300" dirty="0">
+                <a:solidFill>
+                  <a:srgbClr val="1F2933"/>
+                </a:solidFill>
+                <a:latin typeface="Calibri" pitchFamily="34" charset="0"/>
+                <a:ea typeface="Calibri" pitchFamily="34" charset="-122"/>
+                <a:cs typeface="Calibri" pitchFamily="34" charset="-120"/>
+              </a:rPr>
+              <a:t>VMs t2.micro (1 GB) con swap: subir a t3.small</a:t>
+            </a:r>
+            <a:endParaRPr lang="en-US" sz="1300" dirty="0"/>
+          </a:p>
+        </p:txBody>
+      </p:sp>
+      <p:sp>
+        <p:nvSpPr>
+          <p:cNvPr id="6" name="Shape 4"/>
+          <p:cNvSpPr/>
+          <p:nvPr/>
+        </p:nvSpPr>
+        <p:spPr>
+          <a:xfrm>
+            <a:off x="4663440" y="1188720"/>
+            <a:ext cx="4023360" cy="3108960"/>
+          </a:xfrm>
+          <a:prstGeom prst="roundRect">
+            <a:avLst>
+              <a:gd name="adj" fmla="val 2353"/>
+            </a:avLst>
+          </a:prstGeom>
+          <a:solidFill>
+            <a:srgbClr val="F2F4F7"/>
+          </a:solidFill>
+          <a:ln w="9525">
+            <a:solidFill>
+              <a:srgbClr val="E1E5EA"/>
+            </a:solidFill>
+            <a:prstDash val="solid"/>
+          </a:ln>
+        </p:spPr>
+      </p:sp>
+      <p:sp>
+        <p:nvSpPr>
+          <p:cNvPr id="7" name="Text 5"/>
+          <p:cNvSpPr txBox="1"/>
+          <p:nvPr/>
+        </p:nvSpPr>
+        <p:spPr>
+          <a:xfrm>
+            <a:off x="4846320" y="1298448"/>
+            <a:ext cx="3657600" cy="365760"/>
+          </a:xfrm>
+          <a:prstGeom prst="rect">
+            <a:avLst/>
+          </a:prstGeom>
+          <a:noFill/>
+          <a:ln/>
+        </p:spPr>
+        <p:txBody>
+          <a:bodyPr wrap="square" lIns="0" tIns="0" rIns="0" bIns="0" rtlCol="0" anchor="ctr"/>
+          <a:lstStyle/>
+          <a:p>
+            <a:pPr indent="0" marL="0">
+              <a:buNone/>
+            </a:pPr>
+            <a:r>
+              <a:rPr lang="en-US" sz="1600" b="1" dirty="0">
+                <a:solidFill>
+                  <a:srgbClr val="ED7100"/>
+                </a:solidFill>
+                <a:latin typeface="Calibri" pitchFamily="34" charset="0"/>
+                <a:ea typeface="Calibri" pitchFamily="34" charset="-122"/>
+                <a:cs typeface="Calibri" pitchFamily="34" charset="-120"/>
+              </a:rPr>
+              <a:t>Próximos pasos</a:t>
+            </a:r>
+            <a:endParaRPr lang="en-US" sz="1600" dirty="0"/>
+          </a:p>
+        </p:txBody>
+      </p:sp>
+      <p:sp>
+        <p:nvSpPr>
+          <p:cNvPr id="8" name="Text 6"/>
+          <p:cNvSpPr txBox="1"/>
+          <p:nvPr/>
+        </p:nvSpPr>
+        <p:spPr>
+          <a:xfrm>
+            <a:off x="4846320" y="1783080"/>
+            <a:ext cx="3657600" cy="2377440"/>
+          </a:xfrm>
+          <a:prstGeom prst="rect">
+            <a:avLst/>
+          </a:prstGeom>
+          <a:noFill/>
+          <a:ln/>
+        </p:spPr>
+        <p:txBody>
+          <a:bodyPr wrap="square" lIns="0" tIns="0" rIns="0" bIns="0" rtlCol="0" anchor="t"/>
+          <a:lstStyle/>
+          <a:p>
+            <a:pPr marL="342900" indent="-342900">
+              <a:spcAft>
+                <a:spcPts val="800"/>
+              </a:spcAft>
+              <a:buSzPct val="100000"/>
+              <a:buChar char="•"/>
+            </a:pPr>
+            <a:r>
+              <a:rPr lang="en-US" sz="1300" dirty="0">
+                <a:solidFill>
+                  <a:srgbClr val="1F2933"/>
+                </a:solidFill>
+                <a:latin typeface="Calibri" pitchFamily="34" charset="0"/>
+                <a:ea typeface="Calibri" pitchFamily="34" charset="-122"/>
+                <a:cs typeface="Calibri" pitchFamily="34" charset="-120"/>
+              </a:rPr>
+              <a:t>Derivar el usuario de las reseñas del token JWT</a:t>
+            </a:r>
+            <a:endParaRPr lang="en-US" sz="1300" dirty="0"/>
+          </a:p>
+          <a:p>
+            <a:pPr marL="342900" indent="-342900">
+              <a:spcAft>
+                <a:spcPts val="800"/>
+              </a:spcAft>
+              <a:buSzPct val="100000"/>
+              <a:buChar char="•"/>
+            </a:pPr>
+            <a:r>
+              <a:rPr lang="en-US" sz="1300" dirty="0">
+                <a:solidFill>
+                  <a:srgbClr val="1F2933"/>
+                </a:solidFill>
+                <a:latin typeface="Calibri" pitchFamily="34" charset="0"/>
+                <a:ea typeface="Calibri" pitchFamily="34" charset="-122"/>
+                <a:cs typeface="Calibri" pitchFamily="34" charset="-120"/>
+              </a:rPr>
+              <a:t>Programar la ingesta y el crawler (EventBridge)</a:t>
+            </a:r>
+            <a:endParaRPr lang="en-US" sz="1300" dirty="0"/>
+          </a:p>
+          <a:p>
+            <a:pPr marL="342900" indent="-342900">
+              <a:spcAft>
+                <a:spcPts val="800"/>
+              </a:spcAft>
+              <a:buSzPct val="100000"/>
+              <a:buChar char="•"/>
+            </a:pPr>
+            <a:r>
+              <a:rPr lang="en-US" sz="1300" dirty="0">
+                <a:solidFill>
+                  <a:srgbClr val="1F2933"/>
+                </a:solidFill>
+                <a:latin typeface="Calibri" pitchFamily="34" charset="0"/>
+                <a:ea typeface="Calibri" pitchFamily="34" charset="-122"/>
+                <a:cs typeface="Calibri" pitchFamily="34" charset="-120"/>
+              </a:rPr>
+              <a:t>Excluir password_hash del data lake</a:t>
+            </a:r>
+            <a:endParaRPr lang="en-US" sz="1300" dirty="0"/>
+          </a:p>
+        </p:txBody>
+      </p:sp>
+    </p:spTree>
+  </p:cSld>
+  <p:clrMapOvr>
+    <a:masterClrMapping/>
+  </p:clrMapOvr>
+</p:sld>
+</file>
+
+<file path=ppt/slides/slide17.xml><?xml version="1.0" encoding="utf-8"?>
+<p:sld xmlns:a="http://schemas.openxmlformats.org/drawingml/2006/main" xmlns:r="http://schemas.openxmlformats.org/officeDocument/2006/relationships" xmlns:p="http://schemas.openxmlformats.org/presentationml/2006/main">
+  <p:cSld name="Slide 17">
     <p:bg>
       <p:bgPr>
         <a:solidFill>

</xml_diff>

<commit_message>
Amplify con CI/CD desde GitHub: nueva URL y documentacion actualizada
Co-Authored-By: Claude Sonnet 5 <noreply@anthropic.com>
</commit_message>
<xml_diff>
--- a/entregables/Presentacion-Delivery-Cloud.pptx
+++ b/entregables/Presentacion-Delivery-Cloud.pptx
@@ -2695,7 +2695,7 @@
                 <a:ea typeface="Calibri" pitchFamily="34" charset="-122"/>
                 <a:cs typeface="Calibri" pitchFamily="34" charset="-120"/>
               </a:rPr>
-              <a:t>Aplicación: main.duqtfdxa5tvcw.amplifyapp.com</a:t>
+              <a:t>Aplicación: main.d2wzxjgeu63fi4.amplifyapp.com</a:t>
             </a:r>
             <a:endParaRPr lang="en-US" sz="1050" dirty="0"/>
           </a:p>
@@ -7587,27 +7587,6 @@
                 <a:ea typeface="Calibri" pitchFamily="34" charset="-122"/>
                 <a:cs typeface="Calibri" pitchFamily="34" charset="-120"/>
               </a:rPr>
-              <a:t>Amplify se despliega con un zip: conectar GitHub para CI/CD</a:t>
-            </a:r>
-            <a:endParaRPr lang="en-US" sz="1300" dirty="0"/>
-          </a:p>
-          <a:p>
-            <a:pPr marL="342900" indent="-342900">
-              <a:spcAft>
-                <a:spcPts val="800"/>
-              </a:spcAft>
-              <a:buSzPct val="100000"/>
-              <a:buChar char="•"/>
-            </a:pPr>
-            <a:r>
-              <a:rPr lang="en-US" sz="1300" dirty="0">
-                <a:solidFill>
-                  <a:srgbClr val="1F2933"/>
-                </a:solidFill>
-                <a:latin typeface="Calibri" pitchFamily="34" charset="0"/>
-                <a:ea typeface="Calibri" pitchFamily="34" charset="-122"/>
-                <a:cs typeface="Calibri" pitchFamily="34" charset="-120"/>
-              </a:rPr>
               <a:t>VMs t2.micro (1 GB) con swap: subir a t3.small</a:t>
             </a:r>
             <a:endParaRPr lang="en-US" sz="1300" dirty="0"/>
@@ -7739,6 +7718,27 @@
                 <a:cs typeface="Calibri" pitchFamily="34" charset="-120"/>
               </a:rPr>
               <a:t>Programar la ingesta y el crawler (EventBridge)</a:t>
+            </a:r>
+            <a:endParaRPr lang="en-US" sz="1300" dirty="0"/>
+          </a:p>
+          <a:p>
+            <a:pPr marL="342900" indent="-342900">
+              <a:spcAft>
+                <a:spcPts val="800"/>
+              </a:spcAft>
+              <a:buSzPct val="100000"/>
+              <a:buChar char="•"/>
+            </a:pPr>
+            <a:r>
+              <a:rPr lang="en-US" sz="1300" dirty="0">
+                <a:solidFill>
+                  <a:srgbClr val="1F2933"/>
+                </a:solidFill>
+                <a:latin typeface="Calibri" pitchFamily="34" charset="0"/>
+                <a:ea typeface="Calibri" pitchFamily="34" charset="-122"/>
+                <a:cs typeface="Calibri" pitchFamily="34" charset="-120"/>
+              </a:rPr>
+              <a:t>Ejecutar pruebas automáticas en el pipeline de CI</a:t>
             </a:r>
             <a:endParaRPr lang="en-US" sz="1300" dirty="0"/>
           </a:p>
@@ -7976,7 +7976,7 @@
                 <a:ea typeface="Calibri" pitchFamily="34" charset="-122"/>
                 <a:cs typeface="Calibri" pitchFamily="34" charset="-120"/>
               </a:rPr>
-              <a:t>main.duqtfdxa5tvcw.amplifyapp.com</a:t>
+              <a:t>main.d2wzxjgeu63fi4.amplifyapp.com</a:t>
             </a:r>
             <a:endParaRPr lang="en-US" sz="1400" dirty="0"/>
           </a:p>
@@ -12826,7 +12826,7 @@
                 <a:ea typeface="Calibri" pitchFamily="34" charset="-122"/>
                 <a:cs typeface="Calibri" pitchFamily="34" charset="-120"/>
               </a:rPr>
-              <a:t>Consume los 5 microservicios por el API Gateway: 5 · 9 · 8 · 4 · 2 llamadas REST hacia MS1 … MS5 (el mínimo pedido era 2 por servicio).</a:t>
+              <a:t>CI/CD desde GitHub: cada push a main se despliega solo. Consume los 5 microservicios por el API Gateway: 5 · 9 · 8 · 4 · 2 llamadas REST hacia MS1 … MS5 (el mínimo pedido era 2 por servicio).</a:t>
             </a:r>
             <a:endParaRPr lang="en-US" sz="1300" dirty="0"/>
           </a:p>

</xml_diff>

<commit_message>
Prueba E2E completa en el repo y cifras de pruebas actualizadas
Co-Authored-By: Claude Sonnet 5 <noreply@anthropic.com>
</commit_message>
<xml_diff>
--- a/entregables/Presentacion-Delivery-Cloud.pptx
+++ b/entregables/Presentacion-Delivery-Cloud.pptx
@@ -7058,7 +7058,7 @@
                 <a:ea typeface="Calibri" pitchFamily="34" charset="-122"/>
                 <a:cs typeface="Calibri" pitchFamily="34" charset="-120"/>
               </a:rPr>
-              <a:t>72</a:t>
+              <a:t>73</a:t>
             </a:r>
             <a:endParaRPr lang="en-US" sz="3800" dirty="0"/>
           </a:p>
@@ -7097,7 +7097,7 @@
                 <a:ea typeface="Calibri" pitchFamily="34" charset="-122"/>
                 <a:cs typeface="Calibri" pitchFamily="34" charset="-120"/>
               </a:rPr>
-              <a:t>requests de Postman/Newman · 66 aserciones · 0 fallos</a:t>
+              <a:t>requests de Postman/Newman · 69 aserciones · 0 fallos</a:t>
             </a:r>
             <a:endParaRPr lang="en-US" sz="1200" dirty="0"/>
           </a:p>
@@ -7136,7 +7136,7 @@
                 <a:ea typeface="Calibri" pitchFamily="34" charset="-122"/>
                 <a:cs typeface="Calibri" pitchFamily="34" charset="-120"/>
               </a:rPr>
-              <a:t>3 roles</a:t>
+              <a:t>23 / 23</a:t>
             </a:r>
             <a:endParaRPr lang="en-US" sz="3800" dirty="0"/>
           </a:p>
@@ -7175,7 +7175,7 @@
                 <a:ea typeface="Calibri" pitchFamily="34" charset="-122"/>
                 <a:cs typeface="Calibri" pitchFamily="34" charset="-120"/>
               </a:rPr>
-              <a:t>recorridos completos con Playwright sobre la URL de Amplify</a:t>
+              <a:t>comprobaciones del recorrido E2E en navegador (3 roles)</a:t>
             </a:r>
             <a:endParaRPr lang="en-US" sz="1200" dirty="0"/>
           </a:p>
@@ -9243,7 +9243,7 @@
                 <a:ea typeface="Calibri" pitchFamily="34" charset="-122"/>
                 <a:cs typeface="Calibri" pitchFamily="34" charset="-120"/>
               </a:rPr>
-              <a:t>72</a:t>
+              <a:t>73</a:t>
             </a:r>
             <a:endParaRPr lang="en-US" sz="3800" dirty="0"/>
           </a:p>
@@ -9282,7 +9282,7 @@
                 <a:ea typeface="Calibri" pitchFamily="34" charset="-122"/>
                 <a:cs typeface="Calibri" pitchFamily="34" charset="-120"/>
               </a:rPr>
-              <a:t>requests de Postman · 66 aserciones · 0 fallos</a:t>
+              <a:t>requests de Postman · 69 aserciones · 0 fallos</a:t>
             </a:r>
             <a:endParaRPr lang="en-US" sz="1200" dirty="0"/>
           </a:p>

</xml_diff>